<commit_message>
Unify CTIN 290 packet around approved Critical Role cold open
</commit_message>
<xml_diff>
--- a/ctin290-september-21/CLASSROOM/CTIN-290-Classroom-Slides.pptx
+++ b/ctin290-september-21/CLASSROOM/CTIN-290-Classroom-Slides.pptx
@@ -2,27 +2,24 @@
 <file path=ppt/presentation.xml><?xml version="1.0" encoding="utf-8"?>
 <p:presentation xmlns:p="http://schemas.openxmlformats.org/presentationml/2006/main">
   <p:sldMasterIdLst>
-    <p:sldMasterId xmlns:r="http://schemas.openxmlformats.org/officeDocument/2006/relationships" id="2147483648" r:id="R8810bd4d68a343eb"/>
+    <p:sldMasterId xmlns:r="http://schemas.openxmlformats.org/officeDocument/2006/relationships" id="2147483648" r:id="R4cd25eb5d25c47b7"/>
   </p:sldMasterIdLst>
   <p:notesMasterIdLst>
-    <p:notesMasterId xmlns:r="http://schemas.openxmlformats.org/officeDocument/2006/relationships" r:id="R5854e783bf9d4e45"/>
+    <p:notesMasterId xmlns:r="http://schemas.openxmlformats.org/officeDocument/2006/relationships" r:id="Rc58a7acd6fe64d84"/>
   </p:notesMasterIdLst>
   <p:sldIdLst>
-    <p:sldId xmlns:r="http://schemas.openxmlformats.org/officeDocument/2006/relationships" id="256" r:id="R3ff3690ab5fb4e16"/>
-    <p:sldId xmlns:r="http://schemas.openxmlformats.org/officeDocument/2006/relationships" id="257" r:id="R99cfe0a8deaa4cb1"/>
-    <p:sldId xmlns:r="http://schemas.openxmlformats.org/officeDocument/2006/relationships" id="258" r:id="R9c24a2860d904e5b"/>
-    <p:sldId xmlns:r="http://schemas.openxmlformats.org/officeDocument/2006/relationships" id="259" r:id="R587e8856fd714f31"/>
-    <p:sldId xmlns:r="http://schemas.openxmlformats.org/officeDocument/2006/relationships" id="260" r:id="R3c43bd9bf64e4c87"/>
-    <p:sldId xmlns:r="http://schemas.openxmlformats.org/officeDocument/2006/relationships" id="261" r:id="Rae5876b996c04b28"/>
-    <p:sldId xmlns:r="http://schemas.openxmlformats.org/officeDocument/2006/relationships" id="262" r:id="R941f75c8007948c0"/>
-    <p:sldId xmlns:r="http://schemas.openxmlformats.org/officeDocument/2006/relationships" id="263" r:id="Rb831060afd284393"/>
-    <p:sldId xmlns:r="http://schemas.openxmlformats.org/officeDocument/2006/relationships" id="264" r:id="R158422983f344024"/>
-    <p:sldId xmlns:r="http://schemas.openxmlformats.org/officeDocument/2006/relationships" id="265" r:id="Rcf6f3c404a804ccf"/>
-    <p:sldId xmlns:r="http://schemas.openxmlformats.org/officeDocument/2006/relationships" id="266" r:id="R0b8dc0b919af4702"/>
-    <p:sldId xmlns:r="http://schemas.openxmlformats.org/officeDocument/2006/relationships" id="267" r:id="R61fb0903355c4ce4"/>
-    <p:sldId xmlns:r="http://schemas.openxmlformats.org/officeDocument/2006/relationships" id="268" r:id="R7a9f44fdad3d43eb"/>
-    <p:sldId xmlns:r="http://schemas.openxmlformats.org/officeDocument/2006/relationships" id="269" r:id="R62ef0041ba0b45b0"/>
-    <p:sldId xmlns:r="http://schemas.openxmlformats.org/officeDocument/2006/relationships" id="270" r:id="Ra3bf6e003f1c4514"/>
+    <p:sldId xmlns:r="http://schemas.openxmlformats.org/officeDocument/2006/relationships" id="256" r:id="R25435ca1180e41c6"/>
+    <p:sldId xmlns:r="http://schemas.openxmlformats.org/officeDocument/2006/relationships" id="257" r:id="Rf86b660ebff54adf"/>
+    <p:sldId xmlns:r="http://schemas.openxmlformats.org/officeDocument/2006/relationships" id="258" r:id="R2eece5e46cc640c5"/>
+    <p:sldId xmlns:r="http://schemas.openxmlformats.org/officeDocument/2006/relationships" id="259" r:id="Rf7ddd36cbd3c49d0"/>
+    <p:sldId xmlns:r="http://schemas.openxmlformats.org/officeDocument/2006/relationships" id="260" r:id="R3b38b94a2e094407"/>
+    <p:sldId xmlns:r="http://schemas.openxmlformats.org/officeDocument/2006/relationships" id="261" r:id="R5b0a241cec574d3d"/>
+    <p:sldId xmlns:r="http://schemas.openxmlformats.org/officeDocument/2006/relationships" id="262" r:id="R29801966493949b5"/>
+    <p:sldId xmlns:r="http://schemas.openxmlformats.org/officeDocument/2006/relationships" id="263" r:id="R069c8cf6bdec4494"/>
+    <p:sldId xmlns:r="http://schemas.openxmlformats.org/officeDocument/2006/relationships" id="264" r:id="R2acbad06dd534f90"/>
+    <p:sldId xmlns:r="http://schemas.openxmlformats.org/officeDocument/2006/relationships" id="265" r:id="R6cc1a47742c34f20"/>
+    <p:sldId xmlns:r="http://schemas.openxmlformats.org/officeDocument/2006/relationships" id="266" r:id="R72b99dba7dc24bf4"/>
+    <p:sldId xmlns:r="http://schemas.openxmlformats.org/officeDocument/2006/relationships" id="267" r:id="Rb82c25931cda4b68"/>
   </p:sldIdLst>
   <p:sldSz cx="12192000" cy="6858000"/>
   <p:notesSz cx="6858000" cy="9144000"/>
@@ -696,216 +693,6 @@
 </p:notes>
 </file>
 
-<file path=ppt/notesSlides/notesSlide13.xml><?xml version="1.0" encoding="utf-8"?>
-<p:notes xmlns:p="http://schemas.openxmlformats.org/presentationml/2006/main">
-  <p:cSld>
-    <p:spTree>
-      <p:nvGrpSpPr>
-        <p:cNvPr id="1" name=""/>
-        <p:cNvGrpSpPr/>
-        <p:nvPr/>
-      </p:nvGrpSpPr>
-      <p:grpSpPr>
-        <a:xfrm xmlns:a="http://schemas.openxmlformats.org/drawingml/2006/main"/>
-      </p:grpSpPr>
-      <p:sp>
-        <p:nvSpPr>
-          <p:cNvPr id="2" name="Slide Image Placeholder 1"/>
-          <p:cNvSpPr>
-            <a:spLocks xmlns:a="http://schemas.openxmlformats.org/drawingml/2006/main" noGrp="1"/>
-          </p:cNvSpPr>
-          <p:nvPr>
-            <p:ph type="sldImg" idx="0"/>
-          </p:nvPr>
-        </p:nvSpPr>
-        <p:spPr/>
-      </p:sp>
-      <p:sp>
-        <p:nvSpPr>
-          <p:cNvPr id="3" name="Notes Placeholder 2"/>
-          <p:cNvSpPr>
-            <a:spLocks xmlns:a="http://schemas.openxmlformats.org/drawingml/2006/main" noGrp="1"/>
-          </p:cNvSpPr>
-          <p:nvPr>
-            <p:ph type="body" idx="1"/>
-          </p:nvPr>
-        </p:nvSpPr>
-        <p:spPr/>
-        <p:txBody>
-          <a:bodyPr xmlns:a="http://schemas.openxmlformats.org/drawingml/2006/main"/>
-          <a:lstStyle xmlns:a="http://schemas.openxmlformats.org/drawingml/2006/main"/>
-          <a:p xmlns:a="http://schemas.openxmlformats.org/drawingml/2006/main">
-            <a:r>
-              <a:t>CTIN 290, September 21, 2026. Course syllabus and rubric supplied by Gordon. Use the accompanying classroom.html for local interactive exercises.</a:t>
-            </a:r>
-          </a:p>
-        </p:txBody>
-      </p:sp>
-      <p:sp>
-        <p:nvSpPr>
-          <p:cNvPr id="4" name="Slide Number Placeholder 3"/>
-          <p:cNvSpPr>
-            <a:spLocks xmlns:a="http://schemas.openxmlformats.org/drawingml/2006/main" noGrp="1"/>
-          </p:cNvSpPr>
-          <p:nvPr>
-            <p:ph type="sldNum" idx="5"/>
-          </p:nvPr>
-        </p:nvSpPr>
-        <p:spPr/>
-        <p:txBody>
-          <a:bodyPr xmlns:a="http://schemas.openxmlformats.org/drawingml/2006/main"/>
-          <a:lstStyle xmlns:a="http://schemas.openxmlformats.org/drawingml/2006/main"/>
-          <a:p xmlns:a="http://schemas.openxmlformats.org/drawingml/2006/main"/>
-        </p:txBody>
-      </p:sp>
-    </p:spTree>
-  </p:cSld>
-  <p:clrMapOvr>
-    <a:masterClrMapping xmlns:a="http://schemas.openxmlformats.org/drawingml/2006/main"/>
-  </p:clrMapOvr>
-</p:notes>
-</file>
-
-<file path=ppt/notesSlides/notesSlide14.xml><?xml version="1.0" encoding="utf-8"?>
-<p:notes xmlns:p="http://schemas.openxmlformats.org/presentationml/2006/main">
-  <p:cSld>
-    <p:spTree>
-      <p:nvGrpSpPr>
-        <p:cNvPr id="1" name=""/>
-        <p:cNvGrpSpPr/>
-        <p:nvPr/>
-      </p:nvGrpSpPr>
-      <p:grpSpPr>
-        <a:xfrm xmlns:a="http://schemas.openxmlformats.org/drawingml/2006/main"/>
-      </p:grpSpPr>
-      <p:sp>
-        <p:nvSpPr>
-          <p:cNvPr id="2" name="Slide Image Placeholder 1"/>
-          <p:cNvSpPr>
-            <a:spLocks xmlns:a="http://schemas.openxmlformats.org/drawingml/2006/main" noGrp="1"/>
-          </p:cNvSpPr>
-          <p:nvPr>
-            <p:ph type="sldImg" idx="0"/>
-          </p:nvPr>
-        </p:nvSpPr>
-        <p:spPr/>
-      </p:sp>
-      <p:sp>
-        <p:nvSpPr>
-          <p:cNvPr id="3" name="Notes Placeholder 2"/>
-          <p:cNvSpPr>
-            <a:spLocks xmlns:a="http://schemas.openxmlformats.org/drawingml/2006/main" noGrp="1"/>
-          </p:cNvSpPr>
-          <p:nvPr>
-            <p:ph type="body" idx="1"/>
-          </p:nvPr>
-        </p:nvSpPr>
-        <p:spPr/>
-        <p:txBody>
-          <a:bodyPr xmlns:a="http://schemas.openxmlformats.org/drawingml/2006/main"/>
-          <a:lstStyle xmlns:a="http://schemas.openxmlformats.org/drawingml/2006/main"/>
-          <a:p xmlns:a="http://schemas.openxmlformats.org/drawingml/2006/main">
-            <a:r>
-              <a:t>CTIN 290, September 21, 2026. Course syllabus and rubric supplied by Gordon. Use the accompanying classroom.html for local interactive exercises.</a:t>
-            </a:r>
-          </a:p>
-        </p:txBody>
-      </p:sp>
-      <p:sp>
-        <p:nvSpPr>
-          <p:cNvPr id="4" name="Slide Number Placeholder 3"/>
-          <p:cNvSpPr>
-            <a:spLocks xmlns:a="http://schemas.openxmlformats.org/drawingml/2006/main" noGrp="1"/>
-          </p:cNvSpPr>
-          <p:nvPr>
-            <p:ph type="sldNum" idx="5"/>
-          </p:nvPr>
-        </p:nvSpPr>
-        <p:spPr/>
-        <p:txBody>
-          <a:bodyPr xmlns:a="http://schemas.openxmlformats.org/drawingml/2006/main"/>
-          <a:lstStyle xmlns:a="http://schemas.openxmlformats.org/drawingml/2006/main"/>
-          <a:p xmlns:a="http://schemas.openxmlformats.org/drawingml/2006/main"/>
-        </p:txBody>
-      </p:sp>
-    </p:spTree>
-  </p:cSld>
-  <p:clrMapOvr>
-    <a:masterClrMapping xmlns:a="http://schemas.openxmlformats.org/drawingml/2006/main"/>
-  </p:clrMapOvr>
-</p:notes>
-</file>
-
-<file path=ppt/notesSlides/notesSlide15.xml><?xml version="1.0" encoding="utf-8"?>
-<p:notes xmlns:p="http://schemas.openxmlformats.org/presentationml/2006/main">
-  <p:cSld>
-    <p:spTree>
-      <p:nvGrpSpPr>
-        <p:cNvPr id="1" name=""/>
-        <p:cNvGrpSpPr/>
-        <p:nvPr/>
-      </p:nvGrpSpPr>
-      <p:grpSpPr>
-        <a:xfrm xmlns:a="http://schemas.openxmlformats.org/drawingml/2006/main"/>
-      </p:grpSpPr>
-      <p:sp>
-        <p:nvSpPr>
-          <p:cNvPr id="2" name="Slide Image Placeholder 1"/>
-          <p:cNvSpPr>
-            <a:spLocks xmlns:a="http://schemas.openxmlformats.org/drawingml/2006/main" noGrp="1"/>
-          </p:cNvSpPr>
-          <p:nvPr>
-            <p:ph type="sldImg" idx="0"/>
-          </p:nvPr>
-        </p:nvSpPr>
-        <p:spPr/>
-      </p:sp>
-      <p:sp>
-        <p:nvSpPr>
-          <p:cNvPr id="3" name="Notes Placeholder 2"/>
-          <p:cNvSpPr>
-            <a:spLocks xmlns:a="http://schemas.openxmlformats.org/drawingml/2006/main" noGrp="1"/>
-          </p:cNvSpPr>
-          <p:nvPr>
-            <p:ph type="body" idx="1"/>
-          </p:nvPr>
-        </p:nvSpPr>
-        <p:spPr/>
-        <p:txBody>
-          <a:bodyPr xmlns:a="http://schemas.openxmlformats.org/drawingml/2006/main"/>
-          <a:lstStyle xmlns:a="http://schemas.openxmlformats.org/drawingml/2006/main"/>
-          <a:p xmlns:a="http://schemas.openxmlformats.org/drawingml/2006/main">
-            <a:r>
-              <a:t>CTIN 290, September 21, 2026. Course syllabus and rubric supplied by Gordon. Use the accompanying classroom.html for local interactive exercises.</a:t>
-            </a:r>
-          </a:p>
-        </p:txBody>
-      </p:sp>
-      <p:sp>
-        <p:nvSpPr>
-          <p:cNvPr id="4" name="Slide Number Placeholder 3"/>
-          <p:cNvSpPr>
-            <a:spLocks xmlns:a="http://schemas.openxmlformats.org/drawingml/2006/main" noGrp="1"/>
-          </p:cNvSpPr>
-          <p:nvPr>
-            <p:ph type="sldNum" idx="5"/>
-          </p:nvPr>
-        </p:nvSpPr>
-        <p:spPr/>
-        <p:txBody>
-          <a:bodyPr xmlns:a="http://schemas.openxmlformats.org/drawingml/2006/main"/>
-          <a:lstStyle xmlns:a="http://schemas.openxmlformats.org/drawingml/2006/main"/>
-          <a:p xmlns:a="http://schemas.openxmlformats.org/drawingml/2006/main"/>
-        </p:txBody>
-      </p:sp>
-    </p:spTree>
-  </p:cSld>
-  <p:clrMapOvr>
-    <a:masterClrMapping xmlns:a="http://schemas.openxmlformats.org/drawingml/2006/main"/>
-  </p:clrMapOvr>
-</p:notes>
-</file>
-
 <file path=ppt/notesSlides/notesSlide2.xml><?xml version="1.0" encoding="utf-8"?>
 <p:notes xmlns:p="http://schemas.openxmlformats.org/presentationml/2006/main">
   <p:cSld>
@@ -1016,7 +803,7 @@
           <a:lstStyle xmlns:a="http://schemas.openxmlformats.org/drawingml/2006/main"/>
           <a:p xmlns:a="http://schemas.openxmlformats.org/drawingml/2006/main">
             <a:r>
-              <a:t>CTIN 290, September 21, 2026. Course syllabus and rubric supplied by Gordon. Source: https://www.youtube.com/watch?v=DSCKfXpAGHc</a:t>
+              <a:t>CTIN 290, September 21, 2026. Course syllabus and rubric supplied by Gordon. Source: https://www.youtube.com/watch?v=3Mbynm0pGX0&amp;t=0s</a:t>
             </a:r>
           </a:p>
         </p:txBody>
@@ -1086,7 +873,7 @@
           <a:lstStyle xmlns:a="http://schemas.openxmlformats.org/drawingml/2006/main"/>
           <a:p xmlns:a="http://schemas.openxmlformats.org/drawingml/2006/main">
             <a:r>
-              <a:t>CTIN 290, September 21, 2026. Course syllabus and rubric supplied by Gordon. Source: https://www.youtube.com/watch?v=3Mbynm0pGX0&amp;t=448s</a:t>
+              <a:t>CTIN 290, September 21, 2026. Course syllabus and rubric supplied by Gordon. Use the accompanying classroom.html for local interactive exercises.</a:t>
             </a:r>
           </a:p>
         </p:txBody>
@@ -1226,7 +1013,7 @@
           <a:lstStyle xmlns:a="http://schemas.openxmlformats.org/drawingml/2006/main"/>
           <a:p xmlns:a="http://schemas.openxmlformats.org/drawingml/2006/main">
             <a:r>
-              <a:t>CTIN 290, September 21, 2026. Course syllabus and rubric supplied by Gordon. Use the accompanying classroom.html for local interactive exercises.</a:t>
+              <a:t>CTIN 290, September 21, 2026. Course syllabus and rubric supplied by Gordon. Source: https://www.youtube.com/watch?v=DSCKfXpAGHc&amp;t=0s</a:t>
             </a:r>
           </a:p>
         </p:txBody>
@@ -1296,7 +1083,7 @@
           <a:lstStyle xmlns:a="http://schemas.openxmlformats.org/drawingml/2006/main"/>
           <a:p xmlns:a="http://schemas.openxmlformats.org/drawingml/2006/main">
             <a:r>
-              <a:t>CTIN 290, September 21, 2026. Course syllabus and rubric supplied by Gordon. Use the accompanying classroom.html for local interactive exercises.</a:t>
+              <a:t>CTIN 290, September 21, 2026. Course syllabus and rubric supplied by Gordon. Source: https://www.youtube.com/watch?v=3Mbynm0pGX0&amp;t=448s</a:t>
             </a:r>
           </a:p>
         </p:txBody>
@@ -1504,7 +1291,7 @@
   </p:cSld>
   <p:clrMap bg1="lt1" tx1="dk1" bg2="lt2" tx2="dk2" accent1="accent1" accent2="accent2" accent3="accent3" accent4="accent4" accent5="accent5" accent6="accent6" hlink="hlink" folHlink="folHlink"/>
   <p:sldLayoutIdLst>
-    <p:sldLayoutId xmlns:r="http://schemas.openxmlformats.org/officeDocument/2006/relationships" id="2147483649" r:id="Rd1a32d51491a43b3"/>
+    <p:sldLayoutId xmlns:r="http://schemas.openxmlformats.org/officeDocument/2006/relationships" id="2147483649" r:id="R1dbd3a04f21a429d"/>
   </p:sldLayoutIdLst>
   <p:txStyles>
     <p:titleStyle>
@@ -2055,7 +1842,7 @@
           <p:cNvPr id="7" name="">
             <a:extLst xmlns:a="http://schemas.openxmlformats.org/drawingml/2006/main">
               <a:ext uri="{FF2B5EF4-FFF2-40B4-BE49-F238E27FC236}">
-                <a16:creationId xmlns:a16="http://schemas.microsoft.com/office/drawing/2014/main" id="{4EFF2571-394D-4CD1-8B82-6A862A4FA187}"/>
+                <a16:creationId xmlns:a16="http://schemas.microsoft.com/office/drawing/2014/main" id="{6F1B9ADF-0D90-4FEC-B115-B6A1EDB7B01E}"/>
               </a:ext>
             </a:extLst>
           </p:cNvPr>
@@ -2112,7 +1899,7 @@
           <p:cNvPr id="2" name="">
             <a:extLst xmlns:a="http://schemas.openxmlformats.org/drawingml/2006/main">
               <a:ext uri="{FF2B5EF4-FFF2-40B4-BE49-F238E27FC236}">
-                <a16:creationId xmlns:a16="http://schemas.microsoft.com/office/drawing/2014/main" id="{64FCFA4F-8A53-4A42-BACE-6634154D8B9B}"/>
+                <a16:creationId xmlns:a16="http://schemas.microsoft.com/office/drawing/2014/main" id="{AFEF8D46-23DB-4DD1-901E-8EC42783C19C}"/>
               </a:ext>
             </a:extLst>
           </p:cNvPr>
@@ -2169,7 +1956,7 @@
           <p:cNvPr id="3" name="">
             <a:extLst xmlns:a="http://schemas.openxmlformats.org/drawingml/2006/main">
               <a:ext uri="{FF2B5EF4-FFF2-40B4-BE49-F238E27FC236}">
-                <a16:creationId xmlns:a16="http://schemas.microsoft.com/office/drawing/2014/main" id="{0FEAAC3A-704E-4EE6-AE2C-EFBAB25CCF0F}"/>
+                <a16:creationId xmlns:a16="http://schemas.microsoft.com/office/drawing/2014/main" id="{A3F6445C-3824-49C8-9790-C650447887E1}"/>
               </a:ext>
             </a:extLst>
           </p:cNvPr>
@@ -2216,7 +2003,7 @@
                 <a:ea typeface="Noto Sans"/>
                 <a:cs typeface="Noto Sans"/>
               </a:rPr>
-              <a:t>The same action. The same sound. Compare when they meet</a:t>
+              <a:t>The strike stays the same. The sound moves in time</a:t>
             </a:r>
           </a:p>
         </p:txBody>
@@ -2226,7 +2013,7 @@
           <p:cNvPr id="4" name="">
             <a:extLst xmlns:a="http://schemas.openxmlformats.org/drawingml/2006/main">
               <a:ext uri="{FF2B5EF4-FFF2-40B4-BE49-F238E27FC236}">
-                <a16:creationId xmlns:a16="http://schemas.microsoft.com/office/drawing/2014/main" id="{E05FBD64-BAD8-480F-9E09-2F70B1BC4FB6}"/>
+                <a16:creationId xmlns:a16="http://schemas.microsoft.com/office/drawing/2014/main" id="{86AC25DB-2619-4D6F-8FD7-7B27E98522D3}"/>
               </a:ext>
             </a:extLst>
           </p:cNvPr>
@@ -2273,7 +2060,7 @@
                 <a:ea typeface="Noto Sans"/>
                 <a:cs typeface="Noto Sans"/>
               </a:rPr>
-              <a:t>• Does the sound arrive before, with, or after contact?</a:t>
+              <a:t>• Before contact, with contact, or after contact?</a:t>
             </a:r>
           </a:p>
           <a:p xmlns:a="http://schemas.openxmlformats.org/drawingml/2006/main">
@@ -2296,7 +2083,7 @@
                 <a:ea typeface="Noto Sans"/>
                 <a:cs typeface="Noto Sans"/>
               </a:rPr>
-              <a:t>• Point to the event that supports your answer</a:t>
+              <a:t>• Which visible event supports your answer?</a:t>
             </a:r>
           </a:p>
         </p:txBody>
@@ -2306,7 +2093,7 @@
           <p:cNvPr id="5" name="">
             <a:extLst xmlns:a="http://schemas.openxmlformats.org/drawingml/2006/main">
               <a:ext uri="{FF2B5EF4-FFF2-40B4-BE49-F238E27FC236}">
-                <a16:creationId xmlns:a16="http://schemas.microsoft.com/office/drawing/2014/main" id="{1A31E2DD-2007-49CC-874C-C9981D4FCC1C}"/>
+                <a16:creationId xmlns:a16="http://schemas.microsoft.com/office/drawing/2014/main" id="{4C66B37F-A6A6-42A8-9201-F1D8BEC1B436}"/>
               </a:ext>
             </a:extLst>
           </p:cNvPr>
@@ -2363,7 +2150,7 @@
           <p:cNvPr id="6" name="">
             <a:extLst xmlns:a="http://schemas.openxmlformats.org/drawingml/2006/main">
               <a:ext uri="{FF2B5EF4-FFF2-40B4-BE49-F238E27FC236}">
-                <a16:creationId xmlns:a16="http://schemas.microsoft.com/office/drawing/2014/main" id="{03567536-05D1-423C-8B1D-DB14414F1B0F}"/>
+                <a16:creationId xmlns:a16="http://schemas.microsoft.com/office/drawing/2014/main" id="{D63B5781-7FF8-453B-82D0-5D7C97B50F09}"/>
               </a:ext>
             </a:extLst>
           </p:cNvPr>
@@ -2418,7 +2205,7 @@
     </p:spTree>
     <p:extLst>
       <p:ext uri="{BB962C8B-B14F-4D97-AF65-F5344CB8AC3E}">
-        <p14:creationId xmlns:p14="http://schemas.microsoft.com/office/powerpoint/2010/main" val="1445179619"/>
+        <p14:creationId xmlns:p14="http://schemas.microsoft.com/office/powerpoint/2010/main" val="1674305651"/>
       </p:ext>
     </p:extLst>
   </p:cSld>
@@ -2449,7 +2236,7 @@
           <p:cNvPr id="7" name="">
             <a:extLst xmlns:a="http://schemas.openxmlformats.org/drawingml/2006/main">
               <a:ext uri="{FF2B5EF4-FFF2-40B4-BE49-F238E27FC236}">
-                <a16:creationId xmlns:a16="http://schemas.microsoft.com/office/drawing/2014/main" id="{6873CE3B-FBAD-4818-8EAE-7847AC5E05B8}"/>
+                <a16:creationId xmlns:a16="http://schemas.microsoft.com/office/drawing/2014/main" id="{0453CA08-75FC-4E32-806F-8ADF91BECA39}"/>
               </a:ext>
             </a:extLst>
           </p:cNvPr>
@@ -2496,7 +2283,7 @@
                 <a:ea typeface="Noto Sans"/>
                 <a:cs typeface="Noto Sans"/>
               </a:rPr>
-              <a:t>11:30 to 11:40  /  CTIN 290</a:t>
+              <a:t>11:55 to 12:15  /  CTIN 290</a:t>
             </a:r>
           </a:p>
         </p:txBody>
@@ -2506,7 +2293,7 @@
           <p:cNvPr id="2" name="">
             <a:extLst xmlns:a="http://schemas.openxmlformats.org/drawingml/2006/main">
               <a:ext uri="{FF2B5EF4-FFF2-40B4-BE49-F238E27FC236}">
-                <a16:creationId xmlns:a16="http://schemas.microsoft.com/office/drawing/2014/main" id="{D4826631-685B-4435-9B46-2871AB60AF86}"/>
+                <a16:creationId xmlns:a16="http://schemas.microsoft.com/office/drawing/2014/main" id="{AA14CAB4-06E1-4DEE-94C3-E0D98B2FC457}"/>
               </a:ext>
             </a:extLst>
           </p:cNvPr>
@@ -2553,7 +2340,7 @@
                 <a:ea typeface="Noto Sans"/>
                 <a:cs typeface="Noto Sans"/>
               </a:rPr>
-              <a:t>Ten-minute break</a:t>
+              <a:t>Evidence rehearsal and feedback</a:t>
             </a:r>
           </a:p>
         </p:txBody>
@@ -2563,7 +2350,7 @@
           <p:cNvPr id="3" name="">
             <a:extLst xmlns:a="http://schemas.openxmlformats.org/drawingml/2006/main">
               <a:ext uri="{FF2B5EF4-FFF2-40B4-BE49-F238E27FC236}">
-                <a16:creationId xmlns:a16="http://schemas.microsoft.com/office/drawing/2014/main" id="{AAB381D5-99ED-42C0-B4A3-4C6F76AB980D}"/>
+                <a16:creationId xmlns:a16="http://schemas.microsoft.com/office/drawing/2014/main" id="{CDEEC8A6-9E7B-41C2-8D68-886E3B3D3E48}"/>
               </a:ext>
             </a:extLst>
           </p:cNvPr>
@@ -2610,7 +2397,7 @@
                 <a:ea typeface="Noto Sans"/>
                 <a:cs typeface="Noto Sans"/>
               </a:rPr>
-              <a:t>Return at 11:40</a:t>
+              <a:t>Rehearse one claim and the evidence you will show from each form</a:t>
             </a:r>
           </a:p>
         </p:txBody>
@@ -2620,7 +2407,7 @@
           <p:cNvPr id="4" name="">
             <a:extLst xmlns:a="http://schemas.openxmlformats.org/drawingml/2006/main">
               <a:ext uri="{FF2B5EF4-FFF2-40B4-BE49-F238E27FC236}">
-                <a16:creationId xmlns:a16="http://schemas.microsoft.com/office/drawing/2014/main" id="{3C4DC042-B60C-4BCF-BF74-BF8F98940EEF}"/>
+                <a16:creationId xmlns:a16="http://schemas.microsoft.com/office/drawing/2014/main" id="{C2765E7E-2349-47DF-AAF1-56389D49B305}"/>
               </a:ext>
             </a:extLst>
           </p:cNvPr>
@@ -2667,7 +2454,30 @@
                 <a:ea typeface="Noto Sans"/>
                 <a:cs typeface="Noto Sans"/>
               </a:rPr>
-              <a:t>• Take the full ten minutes</a:t>
+              <a:t>• Which frame, action, or cut supports the claim?</a:t>
+            </a:r>
+          </a:p>
+          <a:p xmlns:a="http://schemas.openxmlformats.org/drawingml/2006/main">
+            <a:pPr>
+              <a:defRPr sz="2025" b="0">
+                <a:solidFill>
+                  <a:srgbClr val="17243C"/>
+                </a:solidFill>
+                <a:latin typeface="Noto Sans"/>
+                <a:ea typeface="Noto Sans"/>
+                <a:cs typeface="Noto Sans"/>
+              </a:defRPr>
+            </a:pPr>
+            <a:r>
+              <a:rPr sz="2025" b="0">
+                <a:solidFill>
+                  <a:srgbClr val="17243C"/>
+                </a:solidFill>
+                <a:latin typeface="Noto Sans"/>
+                <a:ea typeface="Noto Sans"/>
+                <a:cs typeface="Noto Sans"/>
+              </a:rPr>
+              <a:t>• What needs to be found or checked?</a:t>
             </a:r>
           </a:p>
         </p:txBody>
@@ -2677,7 +2487,7 @@
           <p:cNvPr id="5" name="">
             <a:extLst xmlns:a="http://schemas.openxmlformats.org/drawingml/2006/main">
               <a:ext uri="{FF2B5EF4-FFF2-40B4-BE49-F238E27FC236}">
-                <a16:creationId xmlns:a16="http://schemas.microsoft.com/office/drawing/2014/main" id="{E6DEF057-AB10-4A53-84F4-19F1C0B6655F}"/>
+                <a16:creationId xmlns:a16="http://schemas.microsoft.com/office/drawing/2014/main" id="{3B8DDEFF-9E9A-44AE-9E31-D6D80D223077}"/>
               </a:ext>
             </a:extLst>
           </p:cNvPr>
@@ -2724,7 +2534,7 @@
                 <a:ea typeface="Noto Sans"/>
                 <a:cs typeface="Noto Sans"/>
               </a:rPr>
-              <a:t>Show the return time (open from the classroom HTML)</a:t>
+              <a:t>Open digital notes (open from the classroom HTML)</a:t>
             </a:r>
           </a:p>
         </p:txBody>
@@ -2734,7 +2544,7 @@
           <p:cNvPr id="6" name="">
             <a:extLst xmlns:a="http://schemas.openxmlformats.org/drawingml/2006/main">
               <a:ext uri="{FF2B5EF4-FFF2-40B4-BE49-F238E27FC236}">
-                <a16:creationId xmlns:a16="http://schemas.microsoft.com/office/drawing/2014/main" id="{E0B29F4F-0C0A-4B39-8A65-F004BEFA2378}"/>
+                <a16:creationId xmlns:a16="http://schemas.microsoft.com/office/drawing/2014/main" id="{4E10D1CA-A135-49D7-B7A6-62B0129D4D0C}"/>
               </a:ext>
             </a:extLst>
           </p:cNvPr>
@@ -2789,7 +2599,7 @@
     </p:spTree>
     <p:extLst>
       <p:ext uri="{BB962C8B-B14F-4D97-AF65-F5344CB8AC3E}">
-        <p14:creationId xmlns:p14="http://schemas.microsoft.com/office/powerpoint/2010/main" val="382088795"/>
+        <p14:creationId xmlns:p14="http://schemas.microsoft.com/office/powerpoint/2010/main" val="1891816546"/>
       </p:ext>
     </p:extLst>
   </p:cSld>
@@ -2820,7 +2630,7 @@
           <p:cNvPr id="7" name="">
             <a:extLst xmlns:a="http://schemas.openxmlformats.org/drawingml/2006/main">
               <a:ext uri="{FF2B5EF4-FFF2-40B4-BE49-F238E27FC236}">
-                <a16:creationId xmlns:a16="http://schemas.microsoft.com/office/drawing/2014/main" id="{161AC90C-6DB9-4B84-80F2-17C212A350C0}"/>
+                <a16:creationId xmlns:a16="http://schemas.microsoft.com/office/drawing/2014/main" id="{4683E450-90C9-4FD7-B68B-A0C144BB6553}"/>
               </a:ext>
             </a:extLst>
           </p:cNvPr>
@@ -2867,7 +2677,7 @@
                 <a:ea typeface="Noto Sans"/>
                 <a:cs typeface="Noto Sans"/>
               </a:rPr>
-              <a:t>11:40 to 11:50  /  CTIN 290</a:t>
+              <a:t>12:15 to 12:45  /  CTIN 290</a:t>
             </a:r>
           </a:p>
         </p:txBody>
@@ -2877,7 +2687,7 @@
           <p:cNvPr id="2" name="">
             <a:extLst xmlns:a="http://schemas.openxmlformats.org/drawingml/2006/main">
               <a:ext uri="{FF2B5EF4-FFF2-40B4-BE49-F238E27FC236}">
-                <a16:creationId xmlns:a16="http://schemas.microsoft.com/office/drawing/2014/main" id="{8445DF8F-7EED-4B13-A2B2-3BA4483F4913}"/>
+                <a16:creationId xmlns:a16="http://schemas.microsoft.com/office/drawing/2014/main" id="{27B222D3-C891-4425-AFF2-164210CBF753}"/>
               </a:ext>
             </a:extLst>
           </p:cNvPr>
@@ -2924,7 +2734,7 @@
                 <a:ea typeface="Noto Sans"/>
                 <a:cs typeface="Noto Sans"/>
               </a:rPr>
-              <a:t>Mood boards · the shared brief</a:t>
+              <a:t>Thirty minutes with your team</a:t>
             </a:r>
           </a:p>
         </p:txBody>
@@ -2934,7 +2744,7 @@
           <p:cNvPr id="3" name="">
             <a:extLst xmlns:a="http://schemas.openxmlformats.org/drawingml/2006/main">
               <a:ext uri="{FF2B5EF4-FFF2-40B4-BE49-F238E27FC236}">
-                <a16:creationId xmlns:a16="http://schemas.microsoft.com/office/drawing/2014/main" id="{BB1A26CA-29EF-40AD-B5E9-84C144B5D323}"/>
+                <a16:creationId xmlns:a16="http://schemas.microsoft.com/office/drawing/2014/main" id="{04D4605E-32F3-4BDE-9DCF-D72E1EC63D87}"/>
               </a:ext>
             </a:extLst>
           </p:cNvPr>
@@ -2981,7 +2791,7 @@
                 <a:ea typeface="Noto Sans"/>
                 <a:cs typeface="Noto Sans"/>
               </a:rPr>
-              <a:t>A game involving collaboration</a:t>
+              <a:t>12:15 to 12:45: work on your actual board for a game involving collaboration</a:t>
             </a:r>
           </a:p>
         </p:txBody>
@@ -2991,7 +2801,7 @@
           <p:cNvPr id="4" name="">
             <a:extLst xmlns:a="http://schemas.openxmlformats.org/drawingml/2006/main">
               <a:ext uri="{FF2B5EF4-FFF2-40B4-BE49-F238E27FC236}">
-                <a16:creationId xmlns:a16="http://schemas.microsoft.com/office/drawing/2014/main" id="{36A1BCDE-4708-410C-9BEB-E0D981D98472}"/>
+                <a16:creationId xmlns:a16="http://schemas.microsoft.com/office/drawing/2014/main" id="{4C507838-DE59-4F93-BCEA-2E9793761623}"/>
               </a:ext>
             </a:extLst>
           </p:cNvPr>
@@ -3038,7 +2848,7 @@
                 <a:ea typeface="Noto Sans"/>
                 <a:cs typeface="Noto Sans"/>
               </a:rPr>
-              <a:t>• 20 to 40 images; visual language, tone, palette and world</a:t>
+              <a:t>• Which visual choice will your team improve?</a:t>
             </a:r>
           </a:p>
           <a:p xmlns:a="http://schemas.openxmlformats.org/drawingml/2006/main">
@@ -3061,7 +2871,7 @@
                 <a:ea typeface="Noto Sans"/>
                 <a:cs typeface="Noto Sans"/>
               </a:rPr>
-              <a:t>• File October 1, 5 PM Pacific; five-minute presentations October 5</a:t>
+              <a:t>• Keep the board somewhere everyone can access</a:t>
             </a:r>
           </a:p>
         </p:txBody>
@@ -3071,7 +2881,7 @@
           <p:cNvPr id="5" name="">
             <a:extLst xmlns:a="http://schemas.openxmlformats.org/drawingml/2006/main">
               <a:ext uri="{FF2B5EF4-FFF2-40B4-BE49-F238E27FC236}">
-                <a16:creationId xmlns:a16="http://schemas.microsoft.com/office/drawing/2014/main" id="{3EAF6621-13E4-4481-850E-9C65CC19191D}"/>
+                <a16:creationId xmlns:a16="http://schemas.microsoft.com/office/drawing/2014/main" id="{B1F6C258-D532-4C10-930F-D8AC39A82C07}"/>
               </a:ext>
             </a:extLst>
           </p:cNvPr>
@@ -3128,7 +2938,7 @@
           <p:cNvPr id="6" name="">
             <a:extLst xmlns:a="http://schemas.openxmlformats.org/drawingml/2006/main">
               <a:ext uri="{FF2B5EF4-FFF2-40B4-BE49-F238E27FC236}">
-                <a16:creationId xmlns:a16="http://schemas.microsoft.com/office/drawing/2014/main" id="{39B7139C-289E-4B51-A139-1D870FC47560}"/>
+                <a16:creationId xmlns:a16="http://schemas.microsoft.com/office/drawing/2014/main" id="{EA78B1A8-E3D1-453B-B4FC-58C459FB311E}"/>
               </a:ext>
             </a:extLst>
           </p:cNvPr>
@@ -3183,7 +2993,7 @@
     </p:spTree>
     <p:extLst>
       <p:ext uri="{BB962C8B-B14F-4D97-AF65-F5344CB8AC3E}">
-        <p14:creationId xmlns:p14="http://schemas.microsoft.com/office/powerpoint/2010/main" val="721728462"/>
+        <p14:creationId xmlns:p14="http://schemas.microsoft.com/office/powerpoint/2010/main" val="217554666"/>
       </p:ext>
     </p:extLst>
   </p:cSld>
@@ -3214,7 +3024,7 @@
           <p:cNvPr id="7" name="">
             <a:extLst xmlns:a="http://schemas.openxmlformats.org/drawingml/2006/main">
               <a:ext uri="{FF2B5EF4-FFF2-40B4-BE49-F238E27FC236}">
-                <a16:creationId xmlns:a16="http://schemas.microsoft.com/office/drawing/2014/main" id="{8AA3A1DF-07E5-446C-96F5-AC5D0588C3ED}"/>
+                <a16:creationId xmlns:a16="http://schemas.microsoft.com/office/drawing/2014/main" id="{FC474292-3316-4320-B940-BC6934421681}"/>
               </a:ext>
             </a:extLst>
           </p:cNvPr>
@@ -3261,7 +3071,7 @@
                 <a:ea typeface="Noto Sans"/>
                 <a:cs typeface="Noto Sans"/>
               </a:rPr>
-              <a:t>11:50 to 12:20  /  CTIN 290</a:t>
+              <a:t>12:45 to 12:50  /  CTIN 290</a:t>
             </a:r>
           </a:p>
         </p:txBody>
@@ -3271,7 +3081,7 @@
           <p:cNvPr id="2" name="">
             <a:extLst xmlns:a="http://schemas.openxmlformats.org/drawingml/2006/main">
               <a:ext uri="{FF2B5EF4-FFF2-40B4-BE49-F238E27FC236}">
-                <a16:creationId xmlns:a16="http://schemas.microsoft.com/office/drawing/2014/main" id="{A722B7F8-CAAD-448A-9264-F4E3D3291915}"/>
+                <a16:creationId xmlns:a16="http://schemas.microsoft.com/office/drawing/2014/main" id="{51BEAAF0-160C-4895-ACA5-D65DC6D758CD}"/>
               </a:ext>
             </a:extLst>
           </p:cNvPr>
@@ -3318,7 +3128,7 @@
                 <a:ea typeface="Noto Sans"/>
                 <a:cs typeface="Noto Sans"/>
               </a:rPr>
-              <a:t>Team Project Time · mood boards</a:t>
+              <a:t>One observation, one question</a:t>
             </a:r>
           </a:p>
         </p:txBody>
@@ -3328,7 +3138,7 @@
           <p:cNvPr id="3" name="">
             <a:extLst xmlns:a="http://schemas.openxmlformats.org/drawingml/2006/main">
               <a:ext uri="{FF2B5EF4-FFF2-40B4-BE49-F238E27FC236}">
-                <a16:creationId xmlns:a16="http://schemas.microsoft.com/office/drawing/2014/main" id="{F0D674DC-6ECF-4E80-8F82-1AE0DF6808FA}"/>
+                <a16:creationId xmlns:a16="http://schemas.microsoft.com/office/drawing/2014/main" id="{60628437-9762-4FB2-AA09-45AABEA03B53}"/>
               </a:ext>
             </a:extLst>
           </p:cNvPr>
@@ -3375,7 +3185,7 @@
                 <a:ea typeface="Noto Sans"/>
                 <a:cs typeface="Noto Sans"/>
               </a:rPr>
-              <a:t>30 uninterrupted minutes on your team’s actual board</a:t>
+              <a:t>One term you learned today and where you saw it. One thing you are still unsure of</a:t>
             </a:r>
           </a:p>
         </p:txBody>
@@ -3385,7 +3195,7 @@
           <p:cNvPr id="4" name="">
             <a:extLst xmlns:a="http://schemas.openxmlformats.org/drawingml/2006/main">
               <a:ext uri="{FF2B5EF4-FFF2-40B4-BE49-F238E27FC236}">
-                <a16:creationId xmlns:a16="http://schemas.microsoft.com/office/drawing/2014/main" id="{DFDAA046-C79F-4FA3-89B9-2483DE9EB82F}"/>
+                <a16:creationId xmlns:a16="http://schemas.microsoft.com/office/drawing/2014/main" id="{364274A5-68DD-4F95-AF4A-4F47B4EAD953}"/>
               </a:ext>
             </a:extLst>
           </p:cNvPr>
@@ -3432,7 +3242,7 @@
                 <a:ea typeface="Noto Sans"/>
                 <a:cs typeface="Noto Sans"/>
               </a:rPr>
-              <a:t>• Make a coherent section. Explain why its references belong</a:t>
+              <a:t>• Save your notes and check shared board access</a:t>
             </a:r>
           </a:p>
           <a:p xmlns:a="http://schemas.openxmlformats.org/drawingml/2006/main">
@@ -3455,7 +3265,7 @@
                 <a:ea typeface="Noto Sans"/>
                 <a:cs typeface="Noto Sans"/>
               </a:rPr>
-              <a:t>• Keep one unresolved visual choice for feedback</a:t>
+              <a:t>• Finish at 12:50</a:t>
             </a:r>
           </a:p>
         </p:txBody>
@@ -3465,7 +3275,7 @@
           <p:cNvPr id="5" name="">
             <a:extLst xmlns:a="http://schemas.openxmlformats.org/drawingml/2006/main">
               <a:ext uri="{FF2B5EF4-FFF2-40B4-BE49-F238E27FC236}">
-                <a16:creationId xmlns:a16="http://schemas.microsoft.com/office/drawing/2014/main" id="{B0FB2327-1AD1-4099-93B0-7BD90D91E26E}"/>
+                <a16:creationId xmlns:a16="http://schemas.microsoft.com/office/drawing/2014/main" id="{42D69EB6-EB1B-4E9C-A105-C16B6BE4E074}"/>
               </a:ext>
             </a:extLst>
           </p:cNvPr>
@@ -3512,7 +3322,7 @@
                 <a:ea typeface="Noto Sans"/>
                 <a:cs typeface="Noto Sans"/>
               </a:rPr>
-              <a:t>Open the 30-minute work block (open from the classroom HTML)</a:t>
+              <a:t>Save your notes (open from the classroom HTML)</a:t>
             </a:r>
           </a:p>
         </p:txBody>
@@ -3522,7 +3332,7 @@
           <p:cNvPr id="6" name="">
             <a:extLst xmlns:a="http://schemas.openxmlformats.org/drawingml/2006/main">
               <a:ext uri="{FF2B5EF4-FFF2-40B4-BE49-F238E27FC236}">
-                <a16:creationId xmlns:a16="http://schemas.microsoft.com/office/drawing/2014/main" id="{1A222B37-EF64-488E-A508-DCBB2B4DF5BD}"/>
+                <a16:creationId xmlns:a16="http://schemas.microsoft.com/office/drawing/2014/main" id="{FE0BE409-CAB2-429C-A28F-5BD4F7FCD1DB}"/>
               </a:ext>
             </a:extLst>
           </p:cNvPr>
@@ -3577,1189 +3387,7 @@
     </p:spTree>
     <p:extLst>
       <p:ext uri="{BB962C8B-B14F-4D97-AF65-F5344CB8AC3E}">
-        <p14:creationId xmlns:p14="http://schemas.microsoft.com/office/powerpoint/2010/main" val="1042497031"/>
-      </p:ext>
-    </p:extLst>
-  </p:cSld>
-</p:sld>
-</file>
-
-<file path=ppt/slides/slide13.xml><?xml version="1.0" encoding="utf-8"?>
-<p:sld xmlns:p="http://schemas.openxmlformats.org/presentationml/2006/main">
-  <p:cSld>
-    <p:bg>
-      <p:bgPr>
-        <a:solidFill xmlns:a="http://schemas.openxmlformats.org/drawingml/2006/main">
-          <a:srgbClr val="F3EFE5"/>
-        </a:solidFill>
-      </p:bgPr>
-    </p:bg>
-    <p:spTree>
-      <p:nvGrpSpPr>
-        <p:cNvPr id="1" name=""/>
-        <p:cNvGrpSpPr/>
-        <p:nvPr/>
-      </p:nvGrpSpPr>
-      <p:grpSpPr>
-        <a:xfrm xmlns:a="http://schemas.openxmlformats.org/drawingml/2006/main"/>
-      </p:grpSpPr>
-      <p:sp>
-        <p:nvSpPr>
-          <p:cNvPr id="7" name="">
-            <a:extLst xmlns:a="http://schemas.openxmlformats.org/drawingml/2006/main">
-              <a:ext uri="{FF2B5EF4-FFF2-40B4-BE49-F238E27FC236}">
-                <a16:creationId xmlns:a16="http://schemas.microsoft.com/office/drawing/2014/main" id="{81B41473-BA56-412B-85B4-4E23ADBAB7BA}"/>
-              </a:ext>
-            </a:extLst>
-          </p:cNvPr>
-          <p:cNvSpPr>
-            <a:spLocks xmlns:a="http://schemas.openxmlformats.org/drawingml/2006/main" noGrp="1"/>
-          </p:cNvSpPr>
-          <p:nvPr/>
-        </p:nvSpPr>
-        <p:spPr>
-          <a:xfrm xmlns:a="http://schemas.openxmlformats.org/drawingml/2006/main">
-            <a:off x="609600" y="333375"/>
-            <a:ext cx="10668000" cy="333375"/>
-          </a:xfrm>
-          <a:prstGeom xmlns:a="http://schemas.openxmlformats.org/drawingml/2006/main" prst="rect">
-            <a:avLst/>
-          </a:prstGeom>
-          <a:noFill xmlns:a="http://schemas.openxmlformats.org/drawingml/2006/main"/>
-          <a:ln xmlns:a="http://schemas.openxmlformats.org/drawingml/2006/main" w="0">
-            <a:noFill/>
-          </a:ln>
-        </p:spPr>
-        <p:txBody>
-          <a:bodyPr xmlns:a="http://schemas.openxmlformats.org/drawingml/2006/main">
-            <a:noAutofit/>
-          </a:bodyPr>
-          <a:lstStyle xmlns:a="http://schemas.openxmlformats.org/drawingml/2006/main"/>
-          <a:p xmlns:a="http://schemas.openxmlformats.org/drawingml/2006/main">
-            <a:pPr>
-              <a:defRPr sz="1275" b="0">
-                <a:solidFill>
-                  <a:srgbClr val="526175"/>
-                </a:solidFill>
-                <a:latin typeface="Noto Sans"/>
-                <a:ea typeface="Noto Sans"/>
-                <a:cs typeface="Noto Sans"/>
-              </a:defRPr>
-            </a:pPr>
-            <a:r>
-              <a:rPr sz="1275" b="0">
-                <a:solidFill>
-                  <a:srgbClr val="526175"/>
-                </a:solidFill>
-                <a:latin typeface="Noto Sans"/>
-                <a:ea typeface="Noto Sans"/>
-                <a:cs typeface="Noto Sans"/>
-              </a:rPr>
-              <a:t>12:20 to 12:35  /  CTIN 290</a:t>
-            </a:r>
-          </a:p>
-        </p:txBody>
-      </p:sp>
-      <p:sp>
-        <p:nvSpPr>
-          <p:cNvPr id="2" name="">
-            <a:extLst xmlns:a="http://schemas.openxmlformats.org/drawingml/2006/main">
-              <a:ext uri="{FF2B5EF4-FFF2-40B4-BE49-F238E27FC236}">
-                <a16:creationId xmlns:a16="http://schemas.microsoft.com/office/drawing/2014/main" id="{478F790A-504B-4622-8545-BF914DA5C256}"/>
-              </a:ext>
-            </a:extLst>
-          </p:cNvPr>
-          <p:cNvSpPr>
-            <a:spLocks xmlns:a="http://schemas.openxmlformats.org/drawingml/2006/main" noGrp="1"/>
-          </p:cNvSpPr>
-          <p:nvPr/>
-        </p:nvSpPr>
-        <p:spPr>
-          <a:xfrm xmlns:a="http://schemas.openxmlformats.org/drawingml/2006/main">
-            <a:off x="609600" y="1057275"/>
-            <a:ext cx="10668000" cy="1476375"/>
-          </a:xfrm>
-          <a:prstGeom xmlns:a="http://schemas.openxmlformats.org/drawingml/2006/main" prst="rect">
-            <a:avLst/>
-          </a:prstGeom>
-          <a:noFill xmlns:a="http://schemas.openxmlformats.org/drawingml/2006/main"/>
-          <a:ln xmlns:a="http://schemas.openxmlformats.org/drawingml/2006/main" w="0">
-            <a:noFill/>
-          </a:ln>
-        </p:spPr>
-        <p:txBody>
-          <a:bodyPr xmlns:a="http://schemas.openxmlformats.org/drawingml/2006/main">
-            <a:noAutofit/>
-          </a:bodyPr>
-          <a:lstStyle xmlns:a="http://schemas.openxmlformats.org/drawingml/2006/main"/>
-          <a:p xmlns:a="http://schemas.openxmlformats.org/drawingml/2006/main">
-            <a:pPr>
-              <a:defRPr sz="4350" b="1">
-                <a:solidFill>
-                  <a:srgbClr val="17243C"/>
-                </a:solidFill>
-                <a:latin typeface="Noto Sans"/>
-                <a:ea typeface="Noto Sans"/>
-                <a:cs typeface="Noto Sans"/>
-              </a:defRPr>
-            </a:pPr>
-            <a:r>
-              <a:rPr sz="4350" b="1">
-                <a:solidFill>
-                  <a:srgbClr val="17243C"/>
-                </a:solidFill>
-                <a:latin typeface="Noto Sans"/>
-                <a:ea typeface="Noto Sans"/>
-                <a:cs typeface="Noto Sans"/>
-              </a:rPr>
-              <a:t>Team-to-team feedback</a:t>
-            </a:r>
-          </a:p>
-        </p:txBody>
-      </p:sp>
-      <p:sp>
-        <p:nvSpPr>
-          <p:cNvPr id="3" name="">
-            <a:extLst xmlns:a="http://schemas.openxmlformats.org/drawingml/2006/main">
-              <a:ext uri="{FF2B5EF4-FFF2-40B4-BE49-F238E27FC236}">
-                <a16:creationId xmlns:a16="http://schemas.microsoft.com/office/drawing/2014/main" id="{1A2E1DC0-DD7F-46E5-9995-5C24529742EB}"/>
-              </a:ext>
-            </a:extLst>
-          </p:cNvPr>
-          <p:cNvSpPr>
-            <a:spLocks xmlns:a="http://schemas.openxmlformats.org/drawingml/2006/main" noGrp="1"/>
-          </p:cNvSpPr>
-          <p:nvPr/>
-        </p:nvSpPr>
-        <p:spPr>
-          <a:xfrm xmlns:a="http://schemas.openxmlformats.org/drawingml/2006/main">
-            <a:off x="628650" y="2781300"/>
-            <a:ext cx="10572750" cy="1295400"/>
-          </a:xfrm>
-          <a:prstGeom xmlns:a="http://schemas.openxmlformats.org/drawingml/2006/main" prst="rect">
-            <a:avLst/>
-          </a:prstGeom>
-          <a:noFill xmlns:a="http://schemas.openxmlformats.org/drawingml/2006/main"/>
-          <a:ln xmlns:a="http://schemas.openxmlformats.org/drawingml/2006/main" w="0">
-            <a:noFill/>
-          </a:ln>
-        </p:spPr>
-        <p:txBody>
-          <a:bodyPr xmlns:a="http://schemas.openxmlformats.org/drawingml/2006/main">
-            <a:noAutofit/>
-          </a:bodyPr>
-          <a:lstStyle xmlns:a="http://schemas.openxmlformats.org/drawingml/2006/main"/>
-          <a:p xmlns:a="http://schemas.openxmlformats.org/drawingml/2006/main">
-            <a:pPr>
-              <a:defRPr sz="2325" b="0">
-                <a:solidFill>
-                  <a:srgbClr val="17243C"/>
-                </a:solidFill>
-                <a:latin typeface="Noto Sans"/>
-                <a:ea typeface="Noto Sans"/>
-                <a:cs typeface="Noto Sans"/>
-              </a:defRPr>
-            </a:pPr>
-            <a:r>
-              <a:rPr sz="2325" b="0">
-                <a:solidFill>
-                  <a:srgbClr val="17243C"/>
-                </a:solidFill>
-                <a:latin typeface="Noto Sans"/>
-                <a:ea typeface="Noto Sans"/>
-                <a:cs typeface="Noto Sans"/>
-              </a:rPr>
-              <a:t>I Like · I Wish · What If</a:t>
-            </a:r>
-          </a:p>
-        </p:txBody>
-      </p:sp>
-      <p:sp>
-        <p:nvSpPr>
-          <p:cNvPr id="4" name="">
-            <a:extLst xmlns:a="http://schemas.openxmlformats.org/drawingml/2006/main">
-              <a:ext uri="{FF2B5EF4-FFF2-40B4-BE49-F238E27FC236}">
-                <a16:creationId xmlns:a16="http://schemas.microsoft.com/office/drawing/2014/main" id="{43D08C7F-E0D1-4B80-B2CB-A93F43D6F938}"/>
-              </a:ext>
-            </a:extLst>
-          </p:cNvPr>
-          <p:cNvSpPr>
-            <a:spLocks xmlns:a="http://schemas.openxmlformats.org/drawingml/2006/main" noGrp="1"/>
-          </p:cNvSpPr>
-          <p:nvPr/>
-        </p:nvSpPr>
-        <p:spPr>
-          <a:xfrm xmlns:a="http://schemas.openxmlformats.org/drawingml/2006/main">
-            <a:off x="628650" y="4419600"/>
-            <a:ext cx="10572750" cy="1333500"/>
-          </a:xfrm>
-          <a:prstGeom xmlns:a="http://schemas.openxmlformats.org/drawingml/2006/main" prst="rect">
-            <a:avLst/>
-          </a:prstGeom>
-          <a:noFill xmlns:a="http://schemas.openxmlformats.org/drawingml/2006/main"/>
-          <a:ln xmlns:a="http://schemas.openxmlformats.org/drawingml/2006/main" w="0">
-            <a:noFill/>
-          </a:ln>
-        </p:spPr>
-        <p:txBody>
-          <a:bodyPr xmlns:a="http://schemas.openxmlformats.org/drawingml/2006/main">
-            <a:noAutofit/>
-          </a:bodyPr>
-          <a:lstStyle xmlns:a="http://schemas.openxmlformats.org/drawingml/2006/main"/>
-          <a:p xmlns:a="http://schemas.openxmlformats.org/drawingml/2006/main">
-            <a:pPr>
-              <a:defRPr sz="2025" b="0">
-                <a:solidFill>
-                  <a:srgbClr val="17243C"/>
-                </a:solidFill>
-                <a:latin typeface="Noto Sans"/>
-                <a:ea typeface="Noto Sans"/>
-                <a:cs typeface="Noto Sans"/>
-              </a:defRPr>
-            </a:pPr>
-            <a:r>
-              <a:rPr sz="2025" b="0">
-                <a:solidFill>
-                  <a:srgbClr val="17243C"/>
-                </a:solidFill>
-                <a:latin typeface="Noto Sans"/>
-                <a:ea typeface="Noto Sans"/>
-                <a:cs typeface="Noto Sans"/>
-              </a:rPr>
-              <a:t>• Name a specific strength, a gap, and a possibility</a:t>
-            </a:r>
-          </a:p>
-          <a:p xmlns:a="http://schemas.openxmlformats.org/drawingml/2006/main">
-            <a:pPr>
-              <a:defRPr sz="2025" b="0">
-                <a:solidFill>
-                  <a:srgbClr val="17243C"/>
-                </a:solidFill>
-                <a:latin typeface="Noto Sans"/>
-                <a:ea typeface="Noto Sans"/>
-                <a:cs typeface="Noto Sans"/>
-              </a:defRPr>
-            </a:pPr>
-            <a:r>
-              <a:rPr sz="2025" b="0">
-                <a:solidFill>
-                  <a:srgbClr val="17243C"/>
-                </a:solidFill>
-                <a:latin typeface="Noto Sans"/>
-                <a:ea typeface="Noto Sans"/>
-                <a:cs typeface="Noto Sans"/>
-              </a:rPr>
-              <a:t>• Point to the visual evidence behind your reading</a:t>
-            </a:r>
-          </a:p>
-        </p:txBody>
-      </p:sp>
-      <p:sp>
-        <p:nvSpPr>
-          <p:cNvPr id="5" name="">
-            <a:extLst xmlns:a="http://schemas.openxmlformats.org/drawingml/2006/main">
-              <a:ext uri="{FF2B5EF4-FFF2-40B4-BE49-F238E27FC236}">
-                <a16:creationId xmlns:a16="http://schemas.microsoft.com/office/drawing/2014/main" id="{B24C3302-55FA-4633-A5F8-3D0FCA213BCB}"/>
-              </a:ext>
-            </a:extLst>
-          </p:cNvPr>
-          <p:cNvSpPr>
-            <a:spLocks xmlns:a="http://schemas.openxmlformats.org/drawingml/2006/main" noGrp="1"/>
-          </p:cNvSpPr>
-          <p:nvPr/>
-        </p:nvSpPr>
-        <p:spPr>
-          <a:xfrm xmlns:a="http://schemas.openxmlformats.org/drawingml/2006/main">
-            <a:off x="628650" y="6019800"/>
-            <a:ext cx="10382250" cy="400050"/>
-          </a:xfrm>
-          <a:prstGeom xmlns:a="http://schemas.openxmlformats.org/drawingml/2006/main" prst="rect">
-            <a:avLst/>
-          </a:prstGeom>
-          <a:noFill xmlns:a="http://schemas.openxmlformats.org/drawingml/2006/main"/>
-          <a:ln xmlns:a="http://schemas.openxmlformats.org/drawingml/2006/main" w="0">
-            <a:noFill/>
-          </a:ln>
-        </p:spPr>
-        <p:txBody>
-          <a:bodyPr xmlns:a="http://schemas.openxmlformats.org/drawingml/2006/main">
-            <a:noAutofit/>
-          </a:bodyPr>
-          <a:lstStyle xmlns:a="http://schemas.openxmlformats.org/drawingml/2006/main"/>
-          <a:p xmlns:a="http://schemas.openxmlformats.org/drawingml/2006/main">
-            <a:pPr>
-              <a:defRPr sz="1200" b="0">
-                <a:solidFill>
-                  <a:srgbClr val="526175"/>
-                </a:solidFill>
-                <a:latin typeface="Noto Sans"/>
-                <a:ea typeface="Noto Sans"/>
-                <a:cs typeface="Noto Sans"/>
-              </a:defRPr>
-            </a:pPr>
-            <a:r>
-              <a:rPr sz="1200" b="0">
-                <a:solidFill>
-                  <a:srgbClr val="526175"/>
-                </a:solidFill>
-                <a:latin typeface="Noto Sans"/>
-                <a:ea typeface="Noto Sans"/>
-                <a:cs typeface="Noto Sans"/>
-              </a:rPr>
-              <a:t>Open the feedback prompts (open from the classroom HTML)</a:t>
-            </a:r>
-          </a:p>
-        </p:txBody>
-      </p:sp>
-      <p:sp>
-        <p:nvSpPr>
-          <p:cNvPr id="6" name="">
-            <a:extLst xmlns:a="http://schemas.openxmlformats.org/drawingml/2006/main">
-              <a:ext uri="{FF2B5EF4-FFF2-40B4-BE49-F238E27FC236}">
-                <a16:creationId xmlns:a16="http://schemas.microsoft.com/office/drawing/2014/main" id="{D03B752F-650D-4545-9BC9-F9844A2883D0}"/>
-              </a:ext>
-            </a:extLst>
-          </p:cNvPr>
-          <p:cNvSpPr>
-            <a:spLocks xmlns:a="http://schemas.openxmlformats.org/drawingml/2006/main" noGrp="1"/>
-          </p:cNvSpPr>
-          <p:nvPr/>
-        </p:nvSpPr>
-        <p:spPr>
-          <a:xfrm xmlns:a="http://schemas.openxmlformats.org/drawingml/2006/main">
-            <a:off x="11172825" y="6276975"/>
-            <a:ext cx="476250" cy="285750"/>
-          </a:xfrm>
-          <a:prstGeom xmlns:a="http://schemas.openxmlformats.org/drawingml/2006/main" prst="rect">
-            <a:avLst/>
-          </a:prstGeom>
-          <a:noFill xmlns:a="http://schemas.openxmlformats.org/drawingml/2006/main"/>
-          <a:ln xmlns:a="http://schemas.openxmlformats.org/drawingml/2006/main" w="0">
-            <a:noFill/>
-          </a:ln>
-        </p:spPr>
-        <p:txBody>
-          <a:bodyPr xmlns:a="http://schemas.openxmlformats.org/drawingml/2006/main">
-            <a:noAutofit/>
-          </a:bodyPr>
-          <a:lstStyle xmlns:a="http://schemas.openxmlformats.org/drawingml/2006/main"/>
-          <a:p xmlns:a="http://schemas.openxmlformats.org/drawingml/2006/main">
-            <a:pPr>
-              <a:defRPr sz="1200" b="0">
-                <a:solidFill>
-                  <a:srgbClr val="526175"/>
-                </a:solidFill>
-                <a:latin typeface="Noto Sans"/>
-                <a:ea typeface="Noto Sans"/>
-                <a:cs typeface="Noto Sans"/>
-              </a:defRPr>
-            </a:pPr>
-            <a:r>
-              <a:rPr sz="1200" b="0">
-                <a:solidFill>
-                  <a:srgbClr val="526175"/>
-                </a:solidFill>
-                <a:latin typeface="Noto Sans"/>
-                <a:ea typeface="Noto Sans"/>
-                <a:cs typeface="Noto Sans"/>
-              </a:rPr>
-              <a:t>13</a:t>
-            </a:r>
-          </a:p>
-        </p:txBody>
-      </p:sp>
-    </p:spTree>
-    <p:extLst>
-      <p:ext uri="{BB962C8B-B14F-4D97-AF65-F5344CB8AC3E}">
-        <p14:creationId xmlns:p14="http://schemas.microsoft.com/office/powerpoint/2010/main" val="836294217"/>
-      </p:ext>
-    </p:extLst>
-  </p:cSld>
-</p:sld>
-</file>
-
-<file path=ppt/slides/slide14.xml><?xml version="1.0" encoding="utf-8"?>
-<p:sld xmlns:p="http://schemas.openxmlformats.org/presentationml/2006/main">
-  <p:cSld>
-    <p:bg>
-      <p:bgPr>
-        <a:solidFill xmlns:a="http://schemas.openxmlformats.org/drawingml/2006/main">
-          <a:srgbClr val="E4EDF2"/>
-        </a:solidFill>
-      </p:bgPr>
-    </p:bg>
-    <p:spTree>
-      <p:nvGrpSpPr>
-        <p:cNvPr id="1" name=""/>
-        <p:cNvGrpSpPr/>
-        <p:nvPr/>
-      </p:nvGrpSpPr>
-      <p:grpSpPr>
-        <a:xfrm xmlns:a="http://schemas.openxmlformats.org/drawingml/2006/main"/>
-      </p:grpSpPr>
-      <p:sp>
-        <p:nvSpPr>
-          <p:cNvPr id="7" name="">
-            <a:extLst xmlns:a="http://schemas.openxmlformats.org/drawingml/2006/main">
-              <a:ext uri="{FF2B5EF4-FFF2-40B4-BE49-F238E27FC236}">
-                <a16:creationId xmlns:a16="http://schemas.microsoft.com/office/drawing/2014/main" id="{320FFAEE-BFFA-443B-B17E-3E7FCE5BBA03}"/>
-              </a:ext>
-            </a:extLst>
-          </p:cNvPr>
-          <p:cNvSpPr>
-            <a:spLocks xmlns:a="http://schemas.openxmlformats.org/drawingml/2006/main" noGrp="1"/>
-          </p:cNvSpPr>
-          <p:nvPr/>
-        </p:nvSpPr>
-        <p:spPr>
-          <a:xfrm xmlns:a="http://schemas.openxmlformats.org/drawingml/2006/main">
-            <a:off x="609600" y="333375"/>
-            <a:ext cx="10668000" cy="333375"/>
-          </a:xfrm>
-          <a:prstGeom xmlns:a="http://schemas.openxmlformats.org/drawingml/2006/main" prst="rect">
-            <a:avLst/>
-          </a:prstGeom>
-          <a:noFill xmlns:a="http://schemas.openxmlformats.org/drawingml/2006/main"/>
-          <a:ln xmlns:a="http://schemas.openxmlformats.org/drawingml/2006/main" w="0">
-            <a:noFill/>
-          </a:ln>
-        </p:spPr>
-        <p:txBody>
-          <a:bodyPr xmlns:a="http://schemas.openxmlformats.org/drawingml/2006/main">
-            <a:noAutofit/>
-          </a:bodyPr>
-          <a:lstStyle xmlns:a="http://schemas.openxmlformats.org/drawingml/2006/main"/>
-          <a:p xmlns:a="http://schemas.openxmlformats.org/drawingml/2006/main">
-            <a:pPr>
-              <a:defRPr sz="1275" b="0">
-                <a:solidFill>
-                  <a:srgbClr val="526175"/>
-                </a:solidFill>
-                <a:latin typeface="Noto Sans"/>
-                <a:ea typeface="Noto Sans"/>
-                <a:cs typeface="Noto Sans"/>
-              </a:defRPr>
-            </a:pPr>
-            <a:r>
-              <a:rPr sz="1275" b="0">
-                <a:solidFill>
-                  <a:srgbClr val="526175"/>
-                </a:solidFill>
-                <a:latin typeface="Noto Sans"/>
-                <a:ea typeface="Noto Sans"/>
-                <a:cs typeface="Noto Sans"/>
-              </a:rPr>
-              <a:t>12:35 to 12:45  /  CTIN 290</a:t>
-            </a:r>
-          </a:p>
-        </p:txBody>
-      </p:sp>
-      <p:sp>
-        <p:nvSpPr>
-          <p:cNvPr id="2" name="">
-            <a:extLst xmlns:a="http://schemas.openxmlformats.org/drawingml/2006/main">
-              <a:ext uri="{FF2B5EF4-FFF2-40B4-BE49-F238E27FC236}">
-                <a16:creationId xmlns:a16="http://schemas.microsoft.com/office/drawing/2014/main" id="{C45C6F62-0373-4232-A65E-C6C9107AD7E7}"/>
-              </a:ext>
-            </a:extLst>
-          </p:cNvPr>
-          <p:cNvSpPr>
-            <a:spLocks xmlns:a="http://schemas.openxmlformats.org/drawingml/2006/main" noGrp="1"/>
-          </p:cNvSpPr>
-          <p:nvPr/>
-        </p:nvSpPr>
-        <p:spPr>
-          <a:xfrm xmlns:a="http://schemas.openxmlformats.org/drawingml/2006/main">
-            <a:off x="609600" y="1057275"/>
-            <a:ext cx="10668000" cy="1476375"/>
-          </a:xfrm>
-          <a:prstGeom xmlns:a="http://schemas.openxmlformats.org/drawingml/2006/main" prst="rect">
-            <a:avLst/>
-          </a:prstGeom>
-          <a:noFill xmlns:a="http://schemas.openxmlformats.org/drawingml/2006/main"/>
-          <a:ln xmlns:a="http://schemas.openxmlformats.org/drawingml/2006/main" w="0">
-            <a:noFill/>
-          </a:ln>
-        </p:spPr>
-        <p:txBody>
-          <a:bodyPr xmlns:a="http://schemas.openxmlformats.org/drawingml/2006/main">
-            <a:noAutofit/>
-          </a:bodyPr>
-          <a:lstStyle xmlns:a="http://schemas.openxmlformats.org/drawingml/2006/main"/>
-          <a:p xmlns:a="http://schemas.openxmlformats.org/drawingml/2006/main">
-            <a:pPr>
-              <a:defRPr sz="4350" b="1">
-                <a:solidFill>
-                  <a:srgbClr val="17243C"/>
-                </a:solidFill>
-                <a:latin typeface="Noto Sans"/>
-                <a:ea typeface="Noto Sans"/>
-                <a:cs typeface="Noto Sans"/>
-              </a:defRPr>
-            </a:pPr>
-            <a:r>
-              <a:rPr sz="4350" b="1">
-                <a:solidFill>
-                  <a:srgbClr val="17243C"/>
-                </a:solidFill>
-                <a:latin typeface="Noto Sans"/>
-                <a:ea typeface="Noto Sans"/>
-                <a:cs typeface="Noto Sans"/>
-              </a:rPr>
-              <a:t>Revise and divide the next work</a:t>
-            </a:r>
-          </a:p>
-        </p:txBody>
-      </p:sp>
-      <p:sp>
-        <p:nvSpPr>
-          <p:cNvPr id="3" name="">
-            <a:extLst xmlns:a="http://schemas.openxmlformats.org/drawingml/2006/main">
-              <a:ext uri="{FF2B5EF4-FFF2-40B4-BE49-F238E27FC236}">
-                <a16:creationId xmlns:a16="http://schemas.microsoft.com/office/drawing/2014/main" id="{41AF5A38-400F-4637-945E-62E66CD7B97B}"/>
-              </a:ext>
-            </a:extLst>
-          </p:cNvPr>
-          <p:cNvSpPr>
-            <a:spLocks xmlns:a="http://schemas.openxmlformats.org/drawingml/2006/main" noGrp="1"/>
-          </p:cNvSpPr>
-          <p:nvPr/>
-        </p:nvSpPr>
-        <p:spPr>
-          <a:xfrm xmlns:a="http://schemas.openxmlformats.org/drawingml/2006/main">
-            <a:off x="628650" y="2781300"/>
-            <a:ext cx="10572750" cy="1295400"/>
-          </a:xfrm>
-          <a:prstGeom xmlns:a="http://schemas.openxmlformats.org/drawingml/2006/main" prst="rect">
-            <a:avLst/>
-          </a:prstGeom>
-          <a:noFill xmlns:a="http://schemas.openxmlformats.org/drawingml/2006/main"/>
-          <a:ln xmlns:a="http://schemas.openxmlformats.org/drawingml/2006/main" w="0">
-            <a:noFill/>
-          </a:ln>
-        </p:spPr>
-        <p:txBody>
-          <a:bodyPr xmlns:a="http://schemas.openxmlformats.org/drawingml/2006/main">
-            <a:noAutofit/>
-          </a:bodyPr>
-          <a:lstStyle xmlns:a="http://schemas.openxmlformats.org/drawingml/2006/main"/>
-          <a:p xmlns:a="http://schemas.openxmlformats.org/drawingml/2006/main">
-            <a:pPr>
-              <a:defRPr sz="2325" b="0">
-                <a:solidFill>
-                  <a:srgbClr val="17243C"/>
-                </a:solidFill>
-                <a:latin typeface="Noto Sans"/>
-                <a:ea typeface="Noto Sans"/>
-                <a:cs typeface="Noto Sans"/>
-              </a:defRPr>
-            </a:pPr>
-            <a:r>
-              <a:rPr sz="2325" b="0">
-                <a:solidFill>
-                  <a:srgbClr val="17243C"/>
-                </a:solidFill>
-                <a:latin typeface="Noto Sans"/>
-                <a:ea typeface="Noto Sans"/>
-                <a:cs typeface="Noto Sans"/>
-              </a:rPr>
-              <a:t>Make one useful revision. Agree who does what next</a:t>
-            </a:r>
-          </a:p>
-        </p:txBody>
-      </p:sp>
-      <p:sp>
-        <p:nvSpPr>
-          <p:cNvPr id="4" name="">
-            <a:extLst xmlns:a="http://schemas.openxmlformats.org/drawingml/2006/main">
-              <a:ext uri="{FF2B5EF4-FFF2-40B4-BE49-F238E27FC236}">
-                <a16:creationId xmlns:a16="http://schemas.microsoft.com/office/drawing/2014/main" id="{8E648563-5463-4A2C-9EB5-5920B9ED4520}"/>
-              </a:ext>
-            </a:extLst>
-          </p:cNvPr>
-          <p:cNvSpPr>
-            <a:spLocks xmlns:a="http://schemas.openxmlformats.org/drawingml/2006/main" noGrp="1"/>
-          </p:cNvSpPr>
-          <p:nvPr/>
-        </p:nvSpPr>
-        <p:spPr>
-          <a:xfrm xmlns:a="http://schemas.openxmlformats.org/drawingml/2006/main">
-            <a:off x="628650" y="4419600"/>
-            <a:ext cx="10572750" cy="1333500"/>
-          </a:xfrm>
-          <a:prstGeom xmlns:a="http://schemas.openxmlformats.org/drawingml/2006/main" prst="rect">
-            <a:avLst/>
-          </a:prstGeom>
-          <a:noFill xmlns:a="http://schemas.openxmlformats.org/drawingml/2006/main"/>
-          <a:ln xmlns:a="http://schemas.openxmlformats.org/drawingml/2006/main" w="0">
-            <a:noFill/>
-          </a:ln>
-        </p:spPr>
-        <p:txBody>
-          <a:bodyPr xmlns:a="http://schemas.openxmlformats.org/drawingml/2006/main">
-            <a:noAutofit/>
-          </a:bodyPr>
-          <a:lstStyle xmlns:a="http://schemas.openxmlformats.org/drawingml/2006/main"/>
-          <a:p xmlns:a="http://schemas.openxmlformats.org/drawingml/2006/main">
-            <a:pPr>
-              <a:defRPr sz="2025" b="0">
-                <a:solidFill>
-                  <a:srgbClr val="17243C"/>
-                </a:solidFill>
-                <a:latin typeface="Noto Sans"/>
-                <a:ea typeface="Noto Sans"/>
-                <a:cs typeface="Noto Sans"/>
-              </a:defRPr>
-            </a:pPr>
-            <a:r>
-              <a:rPr sz="2025" b="0">
-                <a:solidFill>
-                  <a:srgbClr val="17243C"/>
-                </a:solidFill>
-                <a:latin typeface="Noto Sans"/>
-                <a:ea typeface="Noto Sans"/>
-                <a:cs typeface="Noto Sans"/>
-              </a:rPr>
-              <a:t>• Save the board where the whole team can access it</a:t>
-            </a:r>
-          </a:p>
-          <a:p xmlns:a="http://schemas.openxmlformats.org/drawingml/2006/main">
-            <a:pPr>
-              <a:defRPr sz="2025" b="0">
-                <a:solidFill>
-                  <a:srgbClr val="17243C"/>
-                </a:solidFill>
-                <a:latin typeface="Noto Sans"/>
-                <a:ea typeface="Noto Sans"/>
-                <a:cs typeface="Noto Sans"/>
-              </a:defRPr>
-            </a:pPr>
-            <a:r>
-              <a:rPr sz="2025" b="0">
-                <a:solidFill>
-                  <a:srgbClr val="17243C"/>
-                </a:solidFill>
-                <a:latin typeface="Noto Sans"/>
-                <a:ea typeface="Noto Sans"/>
-                <a:cs typeface="Noto Sans"/>
-              </a:rPr>
-              <a:t>• Record one decision and one remaining question</a:t>
-            </a:r>
-          </a:p>
-        </p:txBody>
-      </p:sp>
-      <p:sp>
-        <p:nvSpPr>
-          <p:cNvPr id="5" name="">
-            <a:extLst xmlns:a="http://schemas.openxmlformats.org/drawingml/2006/main">
-              <a:ext uri="{FF2B5EF4-FFF2-40B4-BE49-F238E27FC236}">
-                <a16:creationId xmlns:a16="http://schemas.microsoft.com/office/drawing/2014/main" id="{19A7E0DC-8F95-49A7-8337-F99B576BA156}"/>
-              </a:ext>
-            </a:extLst>
-          </p:cNvPr>
-          <p:cNvSpPr>
-            <a:spLocks xmlns:a="http://schemas.openxmlformats.org/drawingml/2006/main" noGrp="1"/>
-          </p:cNvSpPr>
-          <p:nvPr/>
-        </p:nvSpPr>
-        <p:spPr>
-          <a:xfrm xmlns:a="http://schemas.openxmlformats.org/drawingml/2006/main">
-            <a:off x="628650" y="6019800"/>
-            <a:ext cx="10382250" cy="400050"/>
-          </a:xfrm>
-          <a:prstGeom xmlns:a="http://schemas.openxmlformats.org/drawingml/2006/main" prst="rect">
-            <a:avLst/>
-          </a:prstGeom>
-          <a:noFill xmlns:a="http://schemas.openxmlformats.org/drawingml/2006/main"/>
-          <a:ln xmlns:a="http://schemas.openxmlformats.org/drawingml/2006/main" w="0">
-            <a:noFill/>
-          </a:ln>
-        </p:spPr>
-        <p:txBody>
-          <a:bodyPr xmlns:a="http://schemas.openxmlformats.org/drawingml/2006/main">
-            <a:noAutofit/>
-          </a:bodyPr>
-          <a:lstStyle xmlns:a="http://schemas.openxmlformats.org/drawingml/2006/main"/>
-          <a:p xmlns:a="http://schemas.openxmlformats.org/drawingml/2006/main">
-            <a:pPr>
-              <a:defRPr sz="1200" b="0">
-                <a:solidFill>
-                  <a:srgbClr val="526175"/>
-                </a:solidFill>
-                <a:latin typeface="Noto Sans"/>
-                <a:ea typeface="Noto Sans"/>
-                <a:cs typeface="Noto Sans"/>
-              </a:defRPr>
-            </a:pPr>
-            <a:r>
-              <a:rPr sz="1200" b="0">
-                <a:solidFill>
-                  <a:srgbClr val="526175"/>
-                </a:solidFill>
-                <a:latin typeface="Noto Sans"/>
-                <a:ea typeface="Noto Sans"/>
-                <a:cs typeface="Noto Sans"/>
-              </a:rPr>
-              <a:t>Open the next-step check (open from the classroom HTML)</a:t>
-            </a:r>
-          </a:p>
-        </p:txBody>
-      </p:sp>
-      <p:sp>
-        <p:nvSpPr>
-          <p:cNvPr id="6" name="">
-            <a:extLst xmlns:a="http://schemas.openxmlformats.org/drawingml/2006/main">
-              <a:ext uri="{FF2B5EF4-FFF2-40B4-BE49-F238E27FC236}">
-                <a16:creationId xmlns:a16="http://schemas.microsoft.com/office/drawing/2014/main" id="{7689E32B-E6DD-4037-99C3-3660BE5994A1}"/>
-              </a:ext>
-            </a:extLst>
-          </p:cNvPr>
-          <p:cNvSpPr>
-            <a:spLocks xmlns:a="http://schemas.openxmlformats.org/drawingml/2006/main" noGrp="1"/>
-          </p:cNvSpPr>
-          <p:nvPr/>
-        </p:nvSpPr>
-        <p:spPr>
-          <a:xfrm xmlns:a="http://schemas.openxmlformats.org/drawingml/2006/main">
-            <a:off x="11172825" y="6276975"/>
-            <a:ext cx="476250" cy="285750"/>
-          </a:xfrm>
-          <a:prstGeom xmlns:a="http://schemas.openxmlformats.org/drawingml/2006/main" prst="rect">
-            <a:avLst/>
-          </a:prstGeom>
-          <a:noFill xmlns:a="http://schemas.openxmlformats.org/drawingml/2006/main"/>
-          <a:ln xmlns:a="http://schemas.openxmlformats.org/drawingml/2006/main" w="0">
-            <a:noFill/>
-          </a:ln>
-        </p:spPr>
-        <p:txBody>
-          <a:bodyPr xmlns:a="http://schemas.openxmlformats.org/drawingml/2006/main">
-            <a:noAutofit/>
-          </a:bodyPr>
-          <a:lstStyle xmlns:a="http://schemas.openxmlformats.org/drawingml/2006/main"/>
-          <a:p xmlns:a="http://schemas.openxmlformats.org/drawingml/2006/main">
-            <a:pPr>
-              <a:defRPr sz="1200" b="0">
-                <a:solidFill>
-                  <a:srgbClr val="526175"/>
-                </a:solidFill>
-                <a:latin typeface="Noto Sans"/>
-                <a:ea typeface="Noto Sans"/>
-                <a:cs typeface="Noto Sans"/>
-              </a:defRPr>
-            </a:pPr>
-            <a:r>
-              <a:rPr sz="1200" b="0">
-                <a:solidFill>
-                  <a:srgbClr val="526175"/>
-                </a:solidFill>
-                <a:latin typeface="Noto Sans"/>
-                <a:ea typeface="Noto Sans"/>
-                <a:cs typeface="Noto Sans"/>
-              </a:rPr>
-              <a:t>14</a:t>
-            </a:r>
-          </a:p>
-        </p:txBody>
-      </p:sp>
-    </p:spTree>
-    <p:extLst>
-      <p:ext uri="{BB962C8B-B14F-4D97-AF65-F5344CB8AC3E}">
-        <p14:creationId xmlns:p14="http://schemas.microsoft.com/office/powerpoint/2010/main" val="1905118972"/>
-      </p:ext>
-    </p:extLst>
-  </p:cSld>
-</p:sld>
-</file>
-
-<file path=ppt/slides/slide15.xml><?xml version="1.0" encoding="utf-8"?>
-<p:sld xmlns:p="http://schemas.openxmlformats.org/presentationml/2006/main">
-  <p:cSld>
-    <p:bg>
-      <p:bgPr>
-        <a:solidFill xmlns:a="http://schemas.openxmlformats.org/drawingml/2006/main">
-          <a:srgbClr val="17243C"/>
-        </a:solidFill>
-      </p:bgPr>
-    </p:bg>
-    <p:spTree>
-      <p:nvGrpSpPr>
-        <p:cNvPr id="1" name=""/>
-        <p:cNvGrpSpPr/>
-        <p:nvPr/>
-      </p:nvGrpSpPr>
-      <p:grpSpPr>
-        <a:xfrm xmlns:a="http://schemas.openxmlformats.org/drawingml/2006/main"/>
-      </p:grpSpPr>
-      <p:sp>
-        <p:nvSpPr>
-          <p:cNvPr id="7" name="">
-            <a:extLst xmlns:a="http://schemas.openxmlformats.org/drawingml/2006/main">
-              <a:ext uri="{FF2B5EF4-FFF2-40B4-BE49-F238E27FC236}">
-                <a16:creationId xmlns:a16="http://schemas.microsoft.com/office/drawing/2014/main" id="{D230A75A-4E60-4BB8-9C80-BDD9C408B805}"/>
-              </a:ext>
-            </a:extLst>
-          </p:cNvPr>
-          <p:cNvSpPr>
-            <a:spLocks xmlns:a="http://schemas.openxmlformats.org/drawingml/2006/main" noGrp="1"/>
-          </p:cNvSpPr>
-          <p:nvPr/>
-        </p:nvSpPr>
-        <p:spPr>
-          <a:xfrm xmlns:a="http://schemas.openxmlformats.org/drawingml/2006/main">
-            <a:off x="609600" y="333375"/>
-            <a:ext cx="10668000" cy="333375"/>
-          </a:xfrm>
-          <a:prstGeom xmlns:a="http://schemas.openxmlformats.org/drawingml/2006/main" prst="rect">
-            <a:avLst/>
-          </a:prstGeom>
-          <a:noFill xmlns:a="http://schemas.openxmlformats.org/drawingml/2006/main"/>
-          <a:ln xmlns:a="http://schemas.openxmlformats.org/drawingml/2006/main" w="0">
-            <a:noFill/>
-          </a:ln>
-        </p:spPr>
-        <p:txBody>
-          <a:bodyPr xmlns:a="http://schemas.openxmlformats.org/drawingml/2006/main">
-            <a:noAutofit/>
-          </a:bodyPr>
-          <a:lstStyle xmlns:a="http://schemas.openxmlformats.org/drawingml/2006/main"/>
-          <a:p xmlns:a="http://schemas.openxmlformats.org/drawingml/2006/main">
-            <a:pPr>
-              <a:defRPr sz="1275" b="0">
-                <a:solidFill>
-                  <a:srgbClr val="C6D3E2"/>
-                </a:solidFill>
-                <a:latin typeface="Noto Sans"/>
-                <a:ea typeface="Noto Sans"/>
-                <a:cs typeface="Noto Sans"/>
-              </a:defRPr>
-            </a:pPr>
-            <a:r>
-              <a:rPr sz="1275" b="0">
-                <a:solidFill>
-                  <a:srgbClr val="C6D3E2"/>
-                </a:solidFill>
-                <a:latin typeface="Noto Sans"/>
-                <a:ea typeface="Noto Sans"/>
-                <a:cs typeface="Noto Sans"/>
-              </a:rPr>
-              <a:t>12:45 to 12:50  /  CTIN 290</a:t>
-            </a:r>
-          </a:p>
-        </p:txBody>
-      </p:sp>
-      <p:sp>
-        <p:nvSpPr>
-          <p:cNvPr id="2" name="">
-            <a:extLst xmlns:a="http://schemas.openxmlformats.org/drawingml/2006/main">
-              <a:ext uri="{FF2B5EF4-FFF2-40B4-BE49-F238E27FC236}">
-                <a16:creationId xmlns:a16="http://schemas.microsoft.com/office/drawing/2014/main" id="{068AD940-9C93-45D3-ACAB-AC64AEC41095}"/>
-              </a:ext>
-            </a:extLst>
-          </p:cNvPr>
-          <p:cNvSpPr>
-            <a:spLocks xmlns:a="http://schemas.openxmlformats.org/drawingml/2006/main" noGrp="1"/>
-          </p:cNvSpPr>
-          <p:nvPr/>
-        </p:nvSpPr>
-        <p:spPr>
-          <a:xfrm xmlns:a="http://schemas.openxmlformats.org/drawingml/2006/main">
-            <a:off x="609600" y="1057275"/>
-            <a:ext cx="10668000" cy="1476375"/>
-          </a:xfrm>
-          <a:prstGeom xmlns:a="http://schemas.openxmlformats.org/drawingml/2006/main" prst="rect">
-            <a:avLst/>
-          </a:prstGeom>
-          <a:noFill xmlns:a="http://schemas.openxmlformats.org/drawingml/2006/main"/>
-          <a:ln xmlns:a="http://schemas.openxmlformats.org/drawingml/2006/main" w="0">
-            <a:noFill/>
-          </a:ln>
-        </p:spPr>
-        <p:txBody>
-          <a:bodyPr xmlns:a="http://schemas.openxmlformats.org/drawingml/2006/main">
-            <a:noAutofit/>
-          </a:bodyPr>
-          <a:lstStyle xmlns:a="http://schemas.openxmlformats.org/drawingml/2006/main"/>
-          <a:p xmlns:a="http://schemas.openxmlformats.org/drawingml/2006/main">
-            <a:pPr>
-              <a:defRPr sz="4350" b="1">
-                <a:solidFill>
-                  <a:srgbClr val="F9F5E9"/>
-                </a:solidFill>
-                <a:latin typeface="Noto Sans"/>
-                <a:ea typeface="Noto Sans"/>
-                <a:cs typeface="Noto Sans"/>
-              </a:defRPr>
-            </a:pPr>
-            <a:r>
-              <a:rPr sz="4350" b="1">
-                <a:solidFill>
-                  <a:srgbClr val="F9F5E9"/>
-                </a:solidFill>
-                <a:latin typeface="Noto Sans"/>
-                <a:ea typeface="Noto Sans"/>
-                <a:cs typeface="Noto Sans"/>
-              </a:rPr>
-              <a:t>Exit and next dates</a:t>
-            </a:r>
-          </a:p>
-        </p:txBody>
-      </p:sp>
-      <p:sp>
-        <p:nvSpPr>
-          <p:cNvPr id="3" name="">
-            <a:extLst xmlns:a="http://schemas.openxmlformats.org/drawingml/2006/main">
-              <a:ext uri="{FF2B5EF4-FFF2-40B4-BE49-F238E27FC236}">
-                <a16:creationId xmlns:a16="http://schemas.microsoft.com/office/drawing/2014/main" id="{2C56CE0B-4DF8-4AFF-97B0-85BBDED01BE2}"/>
-              </a:ext>
-            </a:extLst>
-          </p:cNvPr>
-          <p:cNvSpPr>
-            <a:spLocks xmlns:a="http://schemas.openxmlformats.org/drawingml/2006/main" noGrp="1"/>
-          </p:cNvSpPr>
-          <p:nvPr/>
-        </p:nvSpPr>
-        <p:spPr>
-          <a:xfrm xmlns:a="http://schemas.openxmlformats.org/drawingml/2006/main">
-            <a:off x="628650" y="2781300"/>
-            <a:ext cx="10572750" cy="1295400"/>
-          </a:xfrm>
-          <a:prstGeom xmlns:a="http://schemas.openxmlformats.org/drawingml/2006/main" prst="rect">
-            <a:avLst/>
-          </a:prstGeom>
-          <a:noFill xmlns:a="http://schemas.openxmlformats.org/drawingml/2006/main"/>
-          <a:ln xmlns:a="http://schemas.openxmlformats.org/drawingml/2006/main" w="0">
-            <a:noFill/>
-          </a:ln>
-        </p:spPr>
-        <p:txBody>
-          <a:bodyPr xmlns:a="http://schemas.openxmlformats.org/drawingml/2006/main">
-            <a:noAutofit/>
-          </a:bodyPr>
-          <a:lstStyle xmlns:a="http://schemas.openxmlformats.org/drawingml/2006/main"/>
-          <a:p xmlns:a="http://schemas.openxmlformats.org/drawingml/2006/main">
-            <a:pPr>
-              <a:defRPr sz="2325" b="0">
-                <a:solidFill>
-                  <a:srgbClr val="F9F5E9"/>
-                </a:solidFill>
-                <a:latin typeface="Noto Sans"/>
-                <a:ea typeface="Noto Sans"/>
-                <a:cs typeface="Noto Sans"/>
-              </a:defRPr>
-            </a:pPr>
-            <a:r>
-              <a:rPr sz="2325" b="0">
-                <a:solidFill>
-                  <a:srgbClr val="F9F5E9"/>
-                </a:solidFill>
-                <a:latin typeface="Noto Sans"/>
-                <a:ea typeface="Noto Sans"/>
-                <a:cs typeface="Noto Sans"/>
-              </a:rPr>
-              <a:t>One supported observation. One question worth testing</a:t>
-            </a:r>
-          </a:p>
-        </p:txBody>
-      </p:sp>
-      <p:sp>
-        <p:nvSpPr>
-          <p:cNvPr id="4" name="">
-            <a:extLst xmlns:a="http://schemas.openxmlformats.org/drawingml/2006/main">
-              <a:ext uri="{FF2B5EF4-FFF2-40B4-BE49-F238E27FC236}">
-                <a16:creationId xmlns:a16="http://schemas.microsoft.com/office/drawing/2014/main" id="{43852BAF-6E77-4ADD-9D64-8A14D4A1691F}"/>
-              </a:ext>
-            </a:extLst>
-          </p:cNvPr>
-          <p:cNvSpPr>
-            <a:spLocks xmlns:a="http://schemas.openxmlformats.org/drawingml/2006/main" noGrp="1"/>
-          </p:cNvSpPr>
-          <p:nvPr/>
-        </p:nvSpPr>
-        <p:spPr>
-          <a:xfrm xmlns:a="http://schemas.openxmlformats.org/drawingml/2006/main">
-            <a:off x="628650" y="4419600"/>
-            <a:ext cx="10572750" cy="1333500"/>
-          </a:xfrm>
-          <a:prstGeom xmlns:a="http://schemas.openxmlformats.org/drawingml/2006/main" prst="rect">
-            <a:avLst/>
-          </a:prstGeom>
-          <a:noFill xmlns:a="http://schemas.openxmlformats.org/drawingml/2006/main"/>
-          <a:ln xmlns:a="http://schemas.openxmlformats.org/drawingml/2006/main" w="0">
-            <a:noFill/>
-          </a:ln>
-        </p:spPr>
-        <p:txBody>
-          <a:bodyPr xmlns:a="http://schemas.openxmlformats.org/drawingml/2006/main">
-            <a:noAutofit/>
-          </a:bodyPr>
-          <a:lstStyle xmlns:a="http://schemas.openxmlformats.org/drawingml/2006/main"/>
-          <a:p xmlns:a="http://schemas.openxmlformats.org/drawingml/2006/main">
-            <a:pPr>
-              <a:defRPr sz="2025" b="0">
-                <a:solidFill>
-                  <a:srgbClr val="F9F5E9"/>
-                </a:solidFill>
-                <a:latin typeface="Noto Sans"/>
-                <a:ea typeface="Noto Sans"/>
-                <a:cs typeface="Noto Sans"/>
-              </a:defRPr>
-            </a:pPr>
-            <a:r>
-              <a:rPr sz="2025" b="0">
-                <a:solidFill>
-                  <a:srgbClr val="F9F5E9"/>
-                </a:solidFill>
-                <a:latin typeface="Noto Sans"/>
-                <a:ea typeface="Noto Sans"/>
-                <a:cs typeface="Noto Sans"/>
-              </a:rPr>
-              <a:t>• Video essay: September 24, 5 PM Pacific</a:t>
-            </a:r>
-          </a:p>
-          <a:p xmlns:a="http://schemas.openxmlformats.org/drawingml/2006/main">
-            <a:pPr>
-              <a:defRPr sz="2025" b="0">
-                <a:solidFill>
-                  <a:srgbClr val="F9F5E9"/>
-                </a:solidFill>
-                <a:latin typeface="Noto Sans"/>
-                <a:ea typeface="Noto Sans"/>
-                <a:cs typeface="Noto Sans"/>
-              </a:defRPr>
-            </a:pPr>
-            <a:r>
-              <a:rPr sz="2025" b="0">
-                <a:solidFill>
-                  <a:srgbClr val="F9F5E9"/>
-                </a:solidFill>
-                <a:latin typeface="Noto Sans"/>
-                <a:ea typeface="Noto Sans"/>
-                <a:cs typeface="Noto Sans"/>
-              </a:rPr>
-              <a:t>• Mood board: October 1, 5 PM Pacific; presentations October 5</a:t>
-            </a:r>
-          </a:p>
-        </p:txBody>
-      </p:sp>
-      <p:sp>
-        <p:nvSpPr>
-          <p:cNvPr id="5" name="">
-            <a:extLst xmlns:a="http://schemas.openxmlformats.org/drawingml/2006/main">
-              <a:ext uri="{FF2B5EF4-FFF2-40B4-BE49-F238E27FC236}">
-                <a16:creationId xmlns:a16="http://schemas.microsoft.com/office/drawing/2014/main" id="{4DE16740-9D70-43C7-8B4B-0B7F5CACD756}"/>
-              </a:ext>
-            </a:extLst>
-          </p:cNvPr>
-          <p:cNvSpPr>
-            <a:spLocks xmlns:a="http://schemas.openxmlformats.org/drawingml/2006/main" noGrp="1"/>
-          </p:cNvSpPr>
-          <p:nvPr/>
-        </p:nvSpPr>
-        <p:spPr>
-          <a:xfrm xmlns:a="http://schemas.openxmlformats.org/drawingml/2006/main">
-            <a:off x="628650" y="6019800"/>
-            <a:ext cx="10382250" cy="400050"/>
-          </a:xfrm>
-          <a:prstGeom xmlns:a="http://schemas.openxmlformats.org/drawingml/2006/main" prst="rect">
-            <a:avLst/>
-          </a:prstGeom>
-          <a:noFill xmlns:a="http://schemas.openxmlformats.org/drawingml/2006/main"/>
-          <a:ln xmlns:a="http://schemas.openxmlformats.org/drawingml/2006/main" w="0">
-            <a:noFill/>
-          </a:ln>
-        </p:spPr>
-        <p:txBody>
-          <a:bodyPr xmlns:a="http://schemas.openxmlformats.org/drawingml/2006/main">
-            <a:noAutofit/>
-          </a:bodyPr>
-          <a:lstStyle xmlns:a="http://schemas.openxmlformats.org/drawingml/2006/main"/>
-          <a:p xmlns:a="http://schemas.openxmlformats.org/drawingml/2006/main">
-            <a:pPr>
-              <a:defRPr sz="1200" b="0">
-                <a:solidFill>
-                  <a:srgbClr val="C6D3E2"/>
-                </a:solidFill>
-                <a:latin typeface="Noto Sans"/>
-                <a:ea typeface="Noto Sans"/>
-                <a:cs typeface="Noto Sans"/>
-              </a:defRPr>
-            </a:pPr>
-            <a:r>
-              <a:rPr sz="1200" b="0">
-                <a:solidFill>
-                  <a:srgbClr val="C6D3E2"/>
-                </a:solidFill>
-                <a:latin typeface="Noto Sans"/>
-                <a:ea typeface="Noto Sans"/>
-                <a:cs typeface="Noto Sans"/>
-              </a:rPr>
-              <a:t>Open the exit reflection (open from the classroom HTML)</a:t>
-            </a:r>
-          </a:p>
-        </p:txBody>
-      </p:sp>
-      <p:sp>
-        <p:nvSpPr>
-          <p:cNvPr id="6" name="">
-            <a:extLst xmlns:a="http://schemas.openxmlformats.org/drawingml/2006/main">
-              <a:ext uri="{FF2B5EF4-FFF2-40B4-BE49-F238E27FC236}">
-                <a16:creationId xmlns:a16="http://schemas.microsoft.com/office/drawing/2014/main" id="{1FBD04D3-177C-41A4-9B45-05148CB82AF1}"/>
-              </a:ext>
-            </a:extLst>
-          </p:cNvPr>
-          <p:cNvSpPr>
-            <a:spLocks xmlns:a="http://schemas.openxmlformats.org/drawingml/2006/main" noGrp="1"/>
-          </p:cNvSpPr>
-          <p:nvPr/>
-        </p:nvSpPr>
-        <p:spPr>
-          <a:xfrm xmlns:a="http://schemas.openxmlformats.org/drawingml/2006/main">
-            <a:off x="11172825" y="6276975"/>
-            <a:ext cx="476250" cy="285750"/>
-          </a:xfrm>
-          <a:prstGeom xmlns:a="http://schemas.openxmlformats.org/drawingml/2006/main" prst="rect">
-            <a:avLst/>
-          </a:prstGeom>
-          <a:noFill xmlns:a="http://schemas.openxmlformats.org/drawingml/2006/main"/>
-          <a:ln xmlns:a="http://schemas.openxmlformats.org/drawingml/2006/main" w="0">
-            <a:noFill/>
-          </a:ln>
-        </p:spPr>
-        <p:txBody>
-          <a:bodyPr xmlns:a="http://schemas.openxmlformats.org/drawingml/2006/main">
-            <a:noAutofit/>
-          </a:bodyPr>
-          <a:lstStyle xmlns:a="http://schemas.openxmlformats.org/drawingml/2006/main"/>
-          <a:p xmlns:a="http://schemas.openxmlformats.org/drawingml/2006/main">
-            <a:pPr>
-              <a:defRPr sz="1200" b="0">
-                <a:solidFill>
-                  <a:srgbClr val="C6D3E2"/>
-                </a:solidFill>
-                <a:latin typeface="Noto Sans"/>
-                <a:ea typeface="Noto Sans"/>
-                <a:cs typeface="Noto Sans"/>
-              </a:defRPr>
-            </a:pPr>
-            <a:r>
-              <a:rPr sz="1200" b="0">
-                <a:solidFill>
-                  <a:srgbClr val="C6D3E2"/>
-                </a:solidFill>
-                <a:latin typeface="Noto Sans"/>
-                <a:ea typeface="Noto Sans"/>
-                <a:cs typeface="Noto Sans"/>
-              </a:rPr>
-              <a:t>15</a:t>
-            </a:r>
-          </a:p>
-        </p:txBody>
-      </p:sp>
-    </p:spTree>
-    <p:extLst>
-      <p:ext uri="{BB962C8B-B14F-4D97-AF65-F5344CB8AC3E}">
-        <p14:creationId xmlns:p14="http://schemas.microsoft.com/office/powerpoint/2010/main" val="1014600183"/>
+        <p14:creationId xmlns:p14="http://schemas.microsoft.com/office/powerpoint/2010/main" val="1512995659"/>
       </p:ext>
     </p:extLst>
   </p:cSld>
@@ -4790,7 +3418,7 @@
           <p:cNvPr id="7" name="">
             <a:extLst xmlns:a="http://schemas.openxmlformats.org/drawingml/2006/main">
               <a:ext uri="{FF2B5EF4-FFF2-40B4-BE49-F238E27FC236}">
-                <a16:creationId xmlns:a16="http://schemas.microsoft.com/office/drawing/2014/main" id="{C58C12FF-38D1-429E-87A2-5A815F96B393}"/>
+                <a16:creationId xmlns:a16="http://schemas.microsoft.com/office/drawing/2014/main" id="{6D4CB9F4-2258-456D-A2C3-F4765028E95A}"/>
               </a:ext>
             </a:extLst>
           </p:cNvPr>
@@ -4837,7 +3465,7 @@
                 <a:ea typeface="Noto Sans"/>
                 <a:cs typeface="Noto Sans"/>
               </a:rPr>
-              <a:t>10:08 to 10:12  /  CTIN 290</a:t>
+              <a:t>10:08 to 10:10  /  CTIN 290</a:t>
             </a:r>
           </a:p>
         </p:txBody>
@@ -4847,7 +3475,7 @@
           <p:cNvPr id="2" name="">
             <a:extLst xmlns:a="http://schemas.openxmlformats.org/drawingml/2006/main">
               <a:ext uri="{FF2B5EF4-FFF2-40B4-BE49-F238E27FC236}">
-                <a16:creationId xmlns:a16="http://schemas.microsoft.com/office/drawing/2014/main" id="{2D7D26F8-3309-4C3A-AD61-FCB8BA8568BC}"/>
+                <a16:creationId xmlns:a16="http://schemas.microsoft.com/office/drawing/2014/main" id="{1EE47541-91B3-483E-8D2A-45CB31DEFF2F}"/>
               </a:ext>
             </a:extLst>
           </p:cNvPr>
@@ -4894,7 +3522,7 @@
                 <a:ea typeface="Noto Sans"/>
                 <a:cs typeface="Noto Sans"/>
               </a:rPr>
-              <a:t>One question, three tools</a:t>
+              <a:t>Who chooses the view?</a:t>
             </a:r>
           </a:p>
         </p:txBody>
@@ -4904,7 +3532,7 @@
           <p:cNvPr id="3" name="">
             <a:extLst xmlns:a="http://schemas.openxmlformats.org/drawingml/2006/main">
               <a:ext uri="{FF2B5EF4-FFF2-40B4-BE49-F238E27FC236}">
-                <a16:creationId xmlns:a16="http://schemas.microsoft.com/office/drawing/2014/main" id="{D4360F4A-DEFC-478E-B675-E7D181485241}"/>
+                <a16:creationId xmlns:a16="http://schemas.microsoft.com/office/drawing/2014/main" id="{FBFCDE01-D5FE-443F-926D-8A0AE063CA0C}"/>
               </a:ext>
             </a:extLst>
           </p:cNvPr>
@@ -4951,7 +3579,7 @@
                 <a:ea typeface="Noto Sans"/>
                 <a:cs typeface="Noto Sans"/>
               </a:rPr>
-              <a:t>Watch closely. Name the choice. Support the reading</a:t>
+              <a:t>What does the camera help you notice, and what can you no longer choose to watch?</a:t>
             </a:r>
           </a:p>
         </p:txBody>
@@ -4961,7 +3589,7 @@
           <p:cNvPr id="4" name="">
             <a:extLst xmlns:a="http://schemas.openxmlformats.org/drawingml/2006/main">
               <a:ext uri="{FF2B5EF4-FFF2-40B4-BE49-F238E27FC236}">
-                <a16:creationId xmlns:a16="http://schemas.microsoft.com/office/drawing/2014/main" id="{65CD9F74-48DD-4A26-B1EC-C74318E62FC4}"/>
+                <a16:creationId xmlns:a16="http://schemas.microsoft.com/office/drawing/2014/main" id="{28FEC3A8-477D-4263-8AB6-3E9A4003F37A}"/>
               </a:ext>
             </a:extLst>
           </p:cNvPr>
@@ -5008,7 +3636,7 @@
                 <a:ea typeface="Noto Sans"/>
                 <a:cs typeface="Noto Sans"/>
               </a:rPr>
-              <a:t>• Blocking: positions, paths, distance and facing</a:t>
+              <a:t>• Keep one visible action and its timestamp</a:t>
             </a:r>
           </a:p>
           <a:p xmlns:a="http://schemas.openxmlformats.org/drawingml/2006/main">
@@ -5031,30 +3659,7 @@
                 <a:ea typeface="Noto Sans"/>
                 <a:cs typeface="Noto Sans"/>
               </a:rPr>
-              <a:t>• Gesturality: an expressive bodily action</a:t>
-            </a:r>
-          </a:p>
-          <a:p xmlns:a="http://schemas.openxmlformats.org/drawingml/2006/main">
-            <a:pPr>
-              <a:defRPr sz="2025" b="0">
-                <a:solidFill>
-                  <a:srgbClr val="17243C"/>
-                </a:solidFill>
-                <a:latin typeface="Noto Sans"/>
-                <a:ea typeface="Noto Sans"/>
-                <a:cs typeface="Noto Sans"/>
-              </a:defRPr>
-            </a:pPr>
-            <a:r>
-              <a:rPr sz="2025" b="0">
-                <a:solidFill>
-                  <a:srgbClr val="17243C"/>
-                </a:solidFill>
-                <a:latin typeface="Noto Sans"/>
-                <a:ea typeface="Noto Sans"/>
-                <a:cs typeface="Noto Sans"/>
-              </a:rPr>
-              <a:t>• Reaction shot: a view emphasizing a response</a:t>
+              <a:t>• Separate what you see from what you infer</a:t>
             </a:r>
           </a:p>
         </p:txBody>
@@ -5064,7 +3669,7 @@
           <p:cNvPr id="5" name="">
             <a:extLst xmlns:a="http://schemas.openxmlformats.org/drawingml/2006/main">
               <a:ext uri="{FF2B5EF4-FFF2-40B4-BE49-F238E27FC236}">
-                <a16:creationId xmlns:a16="http://schemas.microsoft.com/office/drawing/2014/main" id="{CA73AEA6-E11E-461D-A130-BEF3F3AA7C4A}"/>
+                <a16:creationId xmlns:a16="http://schemas.microsoft.com/office/drawing/2014/main" id="{ABCC4C3F-CF1B-43C6-9DBD-FF7CB358C1DD}"/>
               </a:ext>
             </a:extLst>
           </p:cNvPr>
@@ -5111,7 +3716,7 @@
                 <a:ea typeface="Noto Sans"/>
                 <a:cs typeface="Noto Sans"/>
               </a:rPr>
-              <a:t>Open the student guide (open from the classroom HTML)</a:t>
+              <a:t>Show the viewing question (open from the classroom HTML)</a:t>
             </a:r>
           </a:p>
         </p:txBody>
@@ -5121,7 +3726,7 @@
           <p:cNvPr id="6" name="">
             <a:extLst xmlns:a="http://schemas.openxmlformats.org/drawingml/2006/main">
               <a:ext uri="{FF2B5EF4-FFF2-40B4-BE49-F238E27FC236}">
-                <a16:creationId xmlns:a16="http://schemas.microsoft.com/office/drawing/2014/main" id="{2FDAA312-D628-490D-9E8F-F5D8E3C7ED2B}"/>
+                <a16:creationId xmlns:a16="http://schemas.microsoft.com/office/drawing/2014/main" id="{F29EB21C-D9E4-4DEC-A81E-5581E8FB06F0}"/>
               </a:ext>
             </a:extLst>
           </p:cNvPr>
@@ -5176,7 +3781,7 @@
     </p:spTree>
     <p:extLst>
       <p:ext uri="{BB962C8B-B14F-4D97-AF65-F5344CB8AC3E}">
-        <p14:creationId xmlns:p14="http://schemas.microsoft.com/office/powerpoint/2010/main" val="402154915"/>
+        <p14:creationId xmlns:p14="http://schemas.microsoft.com/office/powerpoint/2010/main" val="1371888933"/>
       </p:ext>
     </p:extLst>
   </p:cSld>
@@ -5207,7 +3812,7 @@
           <p:cNvPr id="7" name="">
             <a:extLst xmlns:a="http://schemas.openxmlformats.org/drawingml/2006/main">
               <a:ext uri="{FF2B5EF4-FFF2-40B4-BE49-F238E27FC236}">
-                <a16:creationId xmlns:a16="http://schemas.microsoft.com/office/drawing/2014/main" id="{AF259563-8241-4DAB-B40F-FCAD67E84D57}"/>
+                <a16:creationId xmlns:a16="http://schemas.microsoft.com/office/drawing/2014/main" id="{F97E7E7E-ACE0-4F92-A1E1-BE4BDD27B532}"/>
               </a:ext>
             </a:extLst>
           </p:cNvPr>
@@ -5254,7 +3859,7 @@
                 <a:ea typeface="Noto Sans"/>
                 <a:cs typeface="Noto Sans"/>
               </a:rPr>
-              <a:t>10:12 to 10:24  /  CTIN 290</a:t>
+              <a:t>10:10 to 10:40  /  CTIN 290</a:t>
             </a:r>
           </a:p>
         </p:txBody>
@@ -5264,7 +3869,7 @@
           <p:cNvPr id="2" name="">
             <a:extLst xmlns:a="http://schemas.openxmlformats.org/drawingml/2006/main">
               <a:ext uri="{FF2B5EF4-FFF2-40B4-BE49-F238E27FC236}">
-                <a16:creationId xmlns:a16="http://schemas.microsoft.com/office/drawing/2014/main" id="{ACF97F5F-74A0-4424-97B4-F3C70EB7C831}"/>
+                <a16:creationId xmlns:a16="http://schemas.microsoft.com/office/drawing/2014/main" id="{460C02BC-C1DA-4127-BA51-83DE631A8C3E}"/>
               </a:ext>
             </a:extLst>
           </p:cNvPr>
@@ -5311,7 +3916,7 @@
                 <a:ea typeface="Noto Sans"/>
                 <a:cs typeface="Noto Sans"/>
               </a:rPr>
-              <a:t>Hamilton · the official trailer</a:t>
+              <a:t>Critical Role: the cold open</a:t>
             </a:r>
           </a:p>
         </p:txBody>
@@ -5321,7 +3926,7 @@
           <p:cNvPr id="3" name="">
             <a:extLst xmlns:a="http://schemas.openxmlformats.org/drawingml/2006/main">
               <a:ext uri="{FF2B5EF4-FFF2-40B4-BE49-F238E27FC236}">
-                <a16:creationId xmlns:a16="http://schemas.microsoft.com/office/drawing/2014/main" id="{253CE529-0F4F-46D5-8FA1-DE2AE7E650C3}"/>
+                <a16:creationId xmlns:a16="http://schemas.microsoft.com/office/drawing/2014/main" id="{B4F59A23-7506-4406-B792-152AE222B065}"/>
               </a:ext>
             </a:extLst>
           </p:cNvPr>
@@ -5368,7 +3973,7 @@
                 <a:ea typeface="Noto Sans"/>
                 <a:cs typeface="Noto Sans"/>
               </a:rPr>
-              <a:t>Watch once. Inspect a frame. Watch again with a question</a:t>
+              <a:t>Main screening: 0:00 to 18:51. Notice how a character becomes legible at the table</a:t>
             </a:r>
           </a:p>
         </p:txBody>
@@ -5378,7 +3983,7 @@
           <p:cNvPr id="4" name="">
             <a:extLst xmlns:a="http://schemas.openxmlformats.org/drawingml/2006/main">
               <a:ext uri="{FF2B5EF4-FFF2-40B4-BE49-F238E27FC236}">
-                <a16:creationId xmlns:a16="http://schemas.microsoft.com/office/drawing/2014/main" id="{5EF736ED-5BCE-4B1B-896C-5D8DA0EB7BAF}"/>
+                <a16:creationId xmlns:a16="http://schemas.microsoft.com/office/drawing/2014/main" id="{B3074001-FD86-4AE8-AFDE-BCA44AF189BF}"/>
               </a:ext>
             </a:extLst>
           </p:cNvPr>
@@ -5425,7 +4030,7 @@
                 <a:ea typeface="Noto Sans"/>
                 <a:cs typeface="Noto Sans"/>
               </a:rPr>
-              <a:t>• At 0:15, what arrangement can you actually see?</a:t>
+              <a:t>• What action or arrangement can you point to?</a:t>
             </a:r>
           </a:p>
           <a:p xmlns:a="http://schemas.openxmlformats.org/drawingml/2006/main">
@@ -5448,7 +4053,7 @@
                 <a:ea typeface="Noto Sans"/>
                 <a:cs typeface="Noto Sans"/>
               </a:rPr>
-              <a:t>• What does a closer view give you? What disappears?</a:t>
+              <a:t>• What was described aloud, and what was visible?</a:t>
             </a:r>
           </a:p>
         </p:txBody>
@@ -5458,7 +4063,7 @@
           <p:cNvPr id="5" name="">
             <a:extLst xmlns:a="http://schemas.openxmlformats.org/drawingml/2006/main">
               <a:ext uri="{FF2B5EF4-FFF2-40B4-BE49-F238E27FC236}">
-                <a16:creationId xmlns:a16="http://schemas.microsoft.com/office/drawing/2014/main" id="{4B94C4A2-3031-4520-8803-28CE35A78A37}"/>
+                <a16:creationId xmlns:a16="http://schemas.microsoft.com/office/drawing/2014/main" id="{ED062523-A520-4A48-8EAD-8E3E1C9446D9}"/>
               </a:ext>
             </a:extLst>
           </p:cNvPr>
@@ -5505,7 +4110,7 @@
                 <a:ea typeface="Noto Sans"/>
                 <a:cs typeface="Noto Sans"/>
               </a:rPr>
-              <a:t>Open the official Hamilton trailer (open from the classroom HTML)</a:t>
+              <a:t>Play Critical Role from 0:00 (open from the classroom HTML)</a:t>
             </a:r>
           </a:p>
         </p:txBody>
@@ -5515,7 +4120,7 @@
           <p:cNvPr id="6" name="">
             <a:extLst xmlns:a="http://schemas.openxmlformats.org/drawingml/2006/main">
               <a:ext uri="{FF2B5EF4-FFF2-40B4-BE49-F238E27FC236}">
-                <a16:creationId xmlns:a16="http://schemas.microsoft.com/office/drawing/2014/main" id="{CA6F65B9-3E94-4B44-AEE4-220EA366AE43}"/>
+                <a16:creationId xmlns:a16="http://schemas.microsoft.com/office/drawing/2014/main" id="{11F6EA76-36D9-41C8-AD91-7C60F9DB2CEF}"/>
               </a:ext>
             </a:extLst>
           </p:cNvPr>
@@ -5570,7 +4175,7 @@
     </p:spTree>
     <p:extLst>
       <p:ext uri="{BB962C8B-B14F-4D97-AF65-F5344CB8AC3E}">
-        <p14:creationId xmlns:p14="http://schemas.microsoft.com/office/powerpoint/2010/main" val="1503681584"/>
+        <p14:creationId xmlns:p14="http://schemas.microsoft.com/office/powerpoint/2010/main" val="2035352725"/>
       </p:ext>
     </p:extLst>
   </p:cSld>
@@ -5601,7 +4206,7 @@
           <p:cNvPr id="7" name="">
             <a:extLst xmlns:a="http://schemas.openxmlformats.org/drawingml/2006/main">
               <a:ext uri="{FF2B5EF4-FFF2-40B4-BE49-F238E27FC236}">
-                <a16:creationId xmlns:a16="http://schemas.microsoft.com/office/drawing/2014/main" id="{319AC089-351B-42BB-A5DF-10CEC6982B6A}"/>
+                <a16:creationId xmlns:a16="http://schemas.microsoft.com/office/drawing/2014/main" id="{BE9048A3-4DE6-4543-B6DB-036673126423}"/>
               </a:ext>
             </a:extLst>
           </p:cNvPr>
@@ -5648,7 +4253,7 @@
                 <a:ea typeface="Noto Sans"/>
                 <a:cs typeface="Noto Sans"/>
               </a:rPr>
-              <a:t>10:24 to 10:36  /  CTIN 290</a:t>
+              <a:t>10:40 to 10:55  /  CTIN 290</a:t>
             </a:r>
           </a:p>
         </p:txBody>
@@ -5658,7 +4263,7 @@
           <p:cNvPr id="2" name="">
             <a:extLst xmlns:a="http://schemas.openxmlformats.org/drawingml/2006/main">
               <a:ext uri="{FF2B5EF4-FFF2-40B4-BE49-F238E27FC236}">
-                <a16:creationId xmlns:a16="http://schemas.microsoft.com/office/drawing/2014/main" id="{0FA568DF-553C-4D27-A970-59029045A6A3}"/>
+                <a16:creationId xmlns:a16="http://schemas.microsoft.com/office/drawing/2014/main" id="{9287F833-2F01-4AFB-A7C4-88EAF55A0F1C}"/>
               </a:ext>
             </a:extLst>
           </p:cNvPr>
@@ -5705,7 +4310,7 @@
                 <a:ea typeface="Noto Sans"/>
                 <a:cs typeface="Noto Sans"/>
               </a:rPr>
-              <a:t>Critical Role · action and response</a:t>
+              <a:t>Three performance tools</a:t>
             </a:r>
           </a:p>
         </p:txBody>
@@ -5715,7 +4320,7 @@
           <p:cNvPr id="3" name="">
             <a:extLst xmlns:a="http://schemas.openxmlformats.org/drawingml/2006/main">
               <a:ext uri="{FF2B5EF4-FFF2-40B4-BE49-F238E27FC236}">
-                <a16:creationId xmlns:a16="http://schemas.microsoft.com/office/drawing/2014/main" id="{80DFB324-0C4D-4657-8B5D-15800FDF1122}"/>
+                <a16:creationId xmlns:a16="http://schemas.microsoft.com/office/drawing/2014/main" id="{692D3274-4E4D-47EC-98A7-3B859FFB8B0D}"/>
               </a:ext>
             </a:extLst>
           </p:cNvPr>
@@ -5762,7 +4367,7 @@
                 <a:ea typeface="Noto Sans"/>
                 <a:cs typeface="Noto Sans"/>
               </a:rPr>
-              <a:t>Watch 7:28 to 8:38. Inspect hands at 7:38; compare speaker at 8:28 and listener at 8:33</a:t>
+              <a:t>Blocking changes the arrangement. Gesture changes the body. Framing changes the view</a:t>
             </a:r>
           </a:p>
         </p:txBody>
@@ -5772,7 +4377,7 @@
           <p:cNvPr id="4" name="">
             <a:extLst xmlns:a="http://schemas.openxmlformats.org/drawingml/2006/main">
               <a:ext uri="{FF2B5EF4-FFF2-40B4-BE49-F238E27FC236}">
-                <a16:creationId xmlns:a16="http://schemas.microsoft.com/office/drawing/2014/main" id="{84B09847-A688-4E7F-8CD8-18D5FE30152C}"/>
+                <a16:creationId xmlns:a16="http://schemas.microsoft.com/office/drawing/2014/main" id="{AAB571E0-641A-41D4-BEC9-C96A1BD9255C}"/>
               </a:ext>
             </a:extLst>
           </p:cNvPr>
@@ -5819,7 +4424,7 @@
                 <a:ea typeface="Noto Sans"/>
                 <a:cs typeface="Noto Sans"/>
               </a:rPr>
-              <a:t>• Describe the action before interpreting it</a:t>
+              <a:t>• Keep the wide view locked for blocking</a:t>
             </a:r>
           </a:p>
           <a:p xmlns:a="http://schemas.openxmlformats.org/drawingml/2006/main">
@@ -5842,7 +4447,7 @@
                 <a:ea typeface="Noto Sans"/>
                 <a:cs typeface="Noto Sans"/>
               </a:rPr>
-              <a:t>• What further moments would establish a recurring gesture?</a:t>
+              <a:t>• Keep the feet fixed for gesture; freeze the response for framing</a:t>
             </a:r>
           </a:p>
         </p:txBody>
@@ -5852,7 +4457,7 @@
           <p:cNvPr id="5" name="">
             <a:extLst xmlns:a="http://schemas.openxmlformats.org/drawingml/2006/main">
               <a:ext uri="{FF2B5EF4-FFF2-40B4-BE49-F238E27FC236}">
-                <a16:creationId xmlns:a16="http://schemas.microsoft.com/office/drawing/2014/main" id="{9505D0C5-E6DE-4865-862F-106A6A923E7B}"/>
+                <a16:creationId xmlns:a16="http://schemas.microsoft.com/office/drawing/2014/main" id="{E45025AE-AEF6-4A8F-A15E-D7B3B892A106}"/>
               </a:ext>
             </a:extLst>
           </p:cNvPr>
@@ -5899,7 +4504,7 @@
                 <a:ea typeface="Noto Sans"/>
                 <a:cs typeface="Noto Sans"/>
               </a:rPr>
-              <a:t>Open Critical Role at 7:28 (open from the classroom HTML)</a:t>
+              <a:t>Open the performance studio (open from the classroom HTML)</a:t>
             </a:r>
           </a:p>
         </p:txBody>
@@ -5909,7 +4514,7 @@
           <p:cNvPr id="6" name="">
             <a:extLst xmlns:a="http://schemas.openxmlformats.org/drawingml/2006/main">
               <a:ext uri="{FF2B5EF4-FFF2-40B4-BE49-F238E27FC236}">
-                <a16:creationId xmlns:a16="http://schemas.microsoft.com/office/drawing/2014/main" id="{EAC082CD-C001-40C7-BAE6-10DE62859281}"/>
+                <a16:creationId xmlns:a16="http://schemas.microsoft.com/office/drawing/2014/main" id="{75C8A4D6-450D-4632-BF1F-15EDC4AF6ED3}"/>
               </a:ext>
             </a:extLst>
           </p:cNvPr>
@@ -5964,7 +4569,7 @@
     </p:spTree>
     <p:extLst>
       <p:ext uri="{BB962C8B-B14F-4D97-AF65-F5344CB8AC3E}">
-        <p14:creationId xmlns:p14="http://schemas.microsoft.com/office/powerpoint/2010/main" val="259017858"/>
+        <p14:creationId xmlns:p14="http://schemas.microsoft.com/office/powerpoint/2010/main" val="1699390106"/>
       </p:ext>
     </p:extLst>
   </p:cSld>
@@ -5995,7 +4600,7 @@
           <p:cNvPr id="7" name="">
             <a:extLst xmlns:a="http://schemas.openxmlformats.org/drawingml/2006/main">
               <a:ext uri="{FF2B5EF4-FFF2-40B4-BE49-F238E27FC236}">
-                <a16:creationId xmlns:a16="http://schemas.microsoft.com/office/drawing/2014/main" id="{7D9BEC4F-587F-41CA-BB19-3F37F0D5656C}"/>
+                <a16:creationId xmlns:a16="http://schemas.microsoft.com/office/drawing/2014/main" id="{28C204D2-820C-48CC-8FAD-9FBCD3DE7538}"/>
               </a:ext>
             </a:extLst>
           </p:cNvPr>
@@ -6042,7 +4647,7 @@
                 <a:ea typeface="Noto Sans"/>
                 <a:cs typeface="Noto Sans"/>
               </a:rPr>
-              <a:t>10:36 to 10:46  /  CTIN 290</a:t>
+              <a:t>10:55 to 11:05  /  CTIN 290</a:t>
             </a:r>
           </a:p>
         </p:txBody>
@@ -6052,7 +4657,7 @@
           <p:cNvPr id="2" name="">
             <a:extLst xmlns:a="http://schemas.openxmlformats.org/drawingml/2006/main">
               <a:ext uri="{FF2B5EF4-FFF2-40B4-BE49-F238E27FC236}">
-                <a16:creationId xmlns:a16="http://schemas.microsoft.com/office/drawing/2014/main" id="{10BF3144-915E-4661-8793-0C291E770D48}"/>
+                <a16:creationId xmlns:a16="http://schemas.microsoft.com/office/drawing/2014/main" id="{E775FAF8-340C-4EAB-A7FB-E6D9F7B91C9C}"/>
               </a:ext>
             </a:extLst>
           </p:cNvPr>
@@ -6099,7 +4704,7 @@
                 <a:ea typeface="Noto Sans"/>
                 <a:cs typeface="Noto Sans"/>
               </a:rPr>
-              <a:t>Blocking · bodies in space</a:t>
+              <a:t>Ten-minute break</a:t>
             </a:r>
           </a:p>
         </p:txBody>
@@ -6109,7 +4714,7 @@
           <p:cNvPr id="3" name="">
             <a:extLst xmlns:a="http://schemas.openxmlformats.org/drawingml/2006/main">
               <a:ext uri="{FF2B5EF4-FFF2-40B4-BE49-F238E27FC236}">
-                <a16:creationId xmlns:a16="http://schemas.microsoft.com/office/drawing/2014/main" id="{7FE3A827-B0E4-44DB-B1CA-1CD0515441CD}"/>
+                <a16:creationId xmlns:a16="http://schemas.microsoft.com/office/drawing/2014/main" id="{0B6FE1B9-6EC3-42BE-91F4-799A1E130715}"/>
               </a:ext>
             </a:extLst>
           </p:cNvPr>
@@ -6156,7 +4761,7 @@
                 <a:ea typeface="Noto Sans"/>
                 <a:cs typeface="Noto Sans"/>
               </a:rPr>
-              <a:t>Same line. Same wide view. Change positions, paths and facing</a:t>
+              <a:t>We return at 11:05</a:t>
             </a:r>
           </a:p>
         </p:txBody>
@@ -6166,7 +4771,7 @@
           <p:cNvPr id="4" name="">
             <a:extLst xmlns:a="http://schemas.openxmlformats.org/drawingml/2006/main">
               <a:ext uri="{FF2B5EF4-FFF2-40B4-BE49-F238E27FC236}">
-                <a16:creationId xmlns:a16="http://schemas.microsoft.com/office/drawing/2014/main" id="{7E77786B-5F34-4CB2-8249-F19247A00BAC}"/>
+                <a16:creationId xmlns:a16="http://schemas.microsoft.com/office/drawing/2014/main" id="{3021F6C8-F7F5-4E9D-82D5-AFB632466B62}"/>
               </a:ext>
             </a:extLst>
           </p:cNvPr>
@@ -6213,7 +4818,7 @@
                 <a:ea typeface="Noto Sans"/>
                 <a:cs typeface="Noto Sans"/>
               </a:rPr>
-              <a:t>• Who moves, and who stays?</a:t>
+              <a:t>• Ten full minutes</a:t>
             </a:r>
           </a:p>
           <a:p xmlns:a="http://schemas.openxmlformats.org/drawingml/2006/main">
@@ -6236,7 +4841,7 @@
                 <a:ea typeface="Noto Sans"/>
                 <a:cs typeface="Noto Sans"/>
               </a:rPr>
-              <a:t>• What changes in their distance or orientation?</a:t>
+              <a:t>• Next: the official Hamilton trailer</a:t>
             </a:r>
           </a:p>
         </p:txBody>
@@ -6246,7 +4851,7 @@
           <p:cNvPr id="5" name="">
             <a:extLst xmlns:a="http://schemas.openxmlformats.org/drawingml/2006/main">
               <a:ext uri="{FF2B5EF4-FFF2-40B4-BE49-F238E27FC236}">
-                <a16:creationId xmlns:a16="http://schemas.microsoft.com/office/drawing/2014/main" id="{8CAD8B8D-E2C7-4196-B43A-37ECB47199DD}"/>
+                <a16:creationId xmlns:a16="http://schemas.microsoft.com/office/drawing/2014/main" id="{2FEF9327-1F4B-47EE-B0EB-313E06B72D23}"/>
               </a:ext>
             </a:extLst>
           </p:cNvPr>
@@ -6293,7 +4898,7 @@
                 <a:ea typeface="Noto Sans"/>
                 <a:cs typeface="Noto Sans"/>
               </a:rPr>
-              <a:t>Open Blocking (open from the classroom HTML)</a:t>
+              <a:t>Show the break slide (open from the classroom HTML)</a:t>
             </a:r>
           </a:p>
         </p:txBody>
@@ -6303,7 +4908,7 @@
           <p:cNvPr id="6" name="">
             <a:extLst xmlns:a="http://schemas.openxmlformats.org/drawingml/2006/main">
               <a:ext uri="{FF2B5EF4-FFF2-40B4-BE49-F238E27FC236}">
-                <a16:creationId xmlns:a16="http://schemas.microsoft.com/office/drawing/2014/main" id="{D4D2E423-BF96-4C2A-8837-1CDAEFEC3C4A}"/>
+                <a16:creationId xmlns:a16="http://schemas.microsoft.com/office/drawing/2014/main" id="{141C78E0-BE91-4704-9C5E-2DAEBA04478E}"/>
               </a:ext>
             </a:extLst>
           </p:cNvPr>
@@ -6358,7 +4963,7 @@
     </p:spTree>
     <p:extLst>
       <p:ext uri="{BB962C8B-B14F-4D97-AF65-F5344CB8AC3E}">
-        <p14:creationId xmlns:p14="http://schemas.microsoft.com/office/powerpoint/2010/main" val="78995364"/>
+        <p14:creationId xmlns:p14="http://schemas.microsoft.com/office/powerpoint/2010/main" val="1583781252"/>
       </p:ext>
     </p:extLst>
   </p:cSld>
@@ -6389,7 +4994,7 @@
           <p:cNvPr id="7" name="">
             <a:extLst xmlns:a="http://schemas.openxmlformats.org/drawingml/2006/main">
               <a:ext uri="{FF2B5EF4-FFF2-40B4-BE49-F238E27FC236}">
-                <a16:creationId xmlns:a16="http://schemas.microsoft.com/office/drawing/2014/main" id="{937A5765-3B8B-4F86-89F7-EEC1C4200BF4}"/>
+                <a16:creationId xmlns:a16="http://schemas.microsoft.com/office/drawing/2014/main" id="{AB2C501F-262D-4015-96FD-5084DB51CC6C}"/>
               </a:ext>
             </a:extLst>
           </p:cNvPr>
@@ -6436,7 +5041,7 @@
                 <a:ea typeface="Noto Sans"/>
                 <a:cs typeface="Noto Sans"/>
               </a:rPr>
-              <a:t>10:46 to 10:54  /  CTIN 290</a:t>
+              <a:t>11:05 to 11:30  /  CTIN 290</a:t>
             </a:r>
           </a:p>
         </p:txBody>
@@ -6446,7 +5051,7 @@
           <p:cNvPr id="2" name="">
             <a:extLst xmlns:a="http://schemas.openxmlformats.org/drawingml/2006/main">
               <a:ext uri="{FF2B5EF4-FFF2-40B4-BE49-F238E27FC236}">
-                <a16:creationId xmlns:a16="http://schemas.microsoft.com/office/drawing/2014/main" id="{49D61E83-350C-45D9-A99D-447EA9B9CF6D}"/>
+                <a16:creationId xmlns:a16="http://schemas.microsoft.com/office/drawing/2014/main" id="{F2259758-23BF-4FD5-AFC6-E59DD816B545}"/>
               </a:ext>
             </a:extLst>
           </p:cNvPr>
@@ -6493,7 +5098,7 @@
                 <a:ea typeface="Noto Sans"/>
                 <a:cs typeface="Noto Sans"/>
               </a:rPr>
-              <a:t>Gesturality · an expressive action</a:t>
+              <a:t>Hamilton: one trailer, three views</a:t>
             </a:r>
           </a:p>
         </p:txBody>
@@ -6503,7 +5108,7 @@
           <p:cNvPr id="3" name="">
             <a:extLst xmlns:a="http://schemas.openxmlformats.org/drawingml/2006/main">
               <a:ext uri="{FF2B5EF4-FFF2-40B4-BE49-F238E27FC236}">
-                <a16:creationId xmlns:a16="http://schemas.microsoft.com/office/drawing/2014/main" id="{44F72453-42E4-49F1-AFF1-41E5F6B8278F}"/>
+                <a16:creationId xmlns:a16="http://schemas.microsoft.com/office/drawing/2014/main" id="{0A11042C-68EA-4748-A493-40EDF3B69362}"/>
               </a:ext>
             </a:extLst>
           </p:cNvPr>
@@ -6550,7 +5155,7 @@
                 <a:ea typeface="Noto Sans"/>
                 <a:cs typeface="Noto Sans"/>
               </a:rPr>
-              <a:t>Keep the feet fixed. Compare an open hand, folded arms and repeated cuff touches</a:t>
+              <a:t>The same one-minute trailer: with sound, muted, then calling the cuts</a:t>
             </a:r>
           </a:p>
         </p:txBody>
@@ -6560,7 +5165,7 @@
           <p:cNvPr id="4" name="">
             <a:extLst xmlns:a="http://schemas.openxmlformats.org/drawingml/2006/main">
               <a:ext uri="{FF2B5EF4-FFF2-40B4-BE49-F238E27FC236}">
-                <a16:creationId xmlns:a16="http://schemas.microsoft.com/office/drawing/2014/main" id="{16D91EC2-1246-4E0F-9615-C2A6F3DF1320}"/>
+                <a16:creationId xmlns:a16="http://schemas.microsoft.com/office/drawing/2014/main" id="{474D4D1A-F189-4DF9-92F3-8C73EAED5A0B}"/>
               </a:ext>
             </a:extLst>
           </p:cNvPr>
@@ -6607,7 +5212,7 @@
                 <a:ea typeface="Noto Sans"/>
                 <a:cs typeface="Noto Sans"/>
               </a:rPr>
-              <a:t>• Name the visible action</a:t>
+              <a:t>• What does a closer view give you?</a:t>
             </a:r>
           </a:p>
           <a:p xmlns:a="http://schemas.openxmlformats.org/drawingml/2006/main">
@@ -6630,7 +5235,7 @@
                 <a:ea typeface="Noto Sans"/>
                 <a:cs typeface="Noto Sans"/>
               </a:rPr>
-              <a:t>• What context would change your interpretation?</a:t>
+              <a:t>• Which simultaneous action becomes harder to inspect?</a:t>
             </a:r>
           </a:p>
         </p:txBody>
@@ -6640,7 +5245,7 @@
           <p:cNvPr id="5" name="">
             <a:extLst xmlns:a="http://schemas.openxmlformats.org/drawingml/2006/main">
               <a:ext uri="{FF2B5EF4-FFF2-40B4-BE49-F238E27FC236}">
-                <a16:creationId xmlns:a16="http://schemas.microsoft.com/office/drawing/2014/main" id="{44286836-D507-48B6-A80C-1E2F032F5378}"/>
+                <a16:creationId xmlns:a16="http://schemas.microsoft.com/office/drawing/2014/main" id="{C92E36CA-053B-4533-B09D-004977381EA2}"/>
               </a:ext>
             </a:extLst>
           </p:cNvPr>
@@ -6687,7 +5292,7 @@
                 <a:ea typeface="Noto Sans"/>
                 <a:cs typeface="Noto Sans"/>
               </a:rPr>
-              <a:t>Open the upgraded Gesturality study (open from the classroom HTML)</a:t>
+              <a:t>Play the official Hamilton trailer (open from the classroom HTML)</a:t>
             </a:r>
           </a:p>
         </p:txBody>
@@ -6697,7 +5302,7 @@
           <p:cNvPr id="6" name="">
             <a:extLst xmlns:a="http://schemas.openxmlformats.org/drawingml/2006/main">
               <a:ext uri="{FF2B5EF4-FFF2-40B4-BE49-F238E27FC236}">
-                <a16:creationId xmlns:a16="http://schemas.microsoft.com/office/drawing/2014/main" id="{01BF036A-91D6-4411-81BA-433A67F2513E}"/>
+                <a16:creationId xmlns:a16="http://schemas.microsoft.com/office/drawing/2014/main" id="{CFE77A63-DD55-45FB-850E-3F7F2A4FA69A}"/>
               </a:ext>
             </a:extLst>
           </p:cNvPr>
@@ -6752,7 +5357,7 @@
     </p:spTree>
     <p:extLst>
       <p:ext uri="{BB962C8B-B14F-4D97-AF65-F5344CB8AC3E}">
-        <p14:creationId xmlns:p14="http://schemas.microsoft.com/office/powerpoint/2010/main" val="529308200"/>
+        <p14:creationId xmlns:p14="http://schemas.microsoft.com/office/powerpoint/2010/main" val="70004093"/>
       </p:ext>
     </p:extLst>
   </p:cSld>
@@ -6783,7 +5388,7 @@
           <p:cNvPr id="7" name="">
             <a:extLst xmlns:a="http://schemas.openxmlformats.org/drawingml/2006/main">
               <a:ext uri="{FF2B5EF4-FFF2-40B4-BE49-F238E27FC236}">
-                <a16:creationId xmlns:a16="http://schemas.microsoft.com/office/drawing/2014/main" id="{9671F63C-8245-4864-912D-3D4BED38CBC7}"/>
+                <a16:creationId xmlns:a16="http://schemas.microsoft.com/office/drawing/2014/main" id="{8B16001D-A17F-4CC2-B444-357669DE7646}"/>
               </a:ext>
             </a:extLst>
           </p:cNvPr>
@@ -6830,7 +5435,7 @@
                 <a:ea typeface="Noto Sans"/>
                 <a:cs typeface="Noto Sans"/>
               </a:rPr>
-              <a:t>10:54 to 11:02  /  CTIN 290</a:t>
+              <a:t>11:30 to 11:38  /  CTIN 290</a:t>
             </a:r>
           </a:p>
         </p:txBody>
@@ -6840,7 +5445,7 @@
           <p:cNvPr id="2" name="">
             <a:extLst xmlns:a="http://schemas.openxmlformats.org/drawingml/2006/main">
               <a:ext uri="{FF2B5EF4-FFF2-40B4-BE49-F238E27FC236}">
-                <a16:creationId xmlns:a16="http://schemas.microsoft.com/office/drawing/2014/main" id="{FE9B0747-218C-48E8-A29E-86C7C1203923}"/>
+                <a16:creationId xmlns:a16="http://schemas.microsoft.com/office/drawing/2014/main" id="{C3CE72FD-978E-4B54-B0FF-ACAFE7D050E3}"/>
               </a:ext>
             </a:extLst>
           </p:cNvPr>
@@ -6887,7 +5492,7 @@
                 <a:ea typeface="Noto Sans"/>
                 <a:cs typeface="Noto Sans"/>
               </a:rPr>
-              <a:t>Reaction shot · whose response?</a:t>
+              <a:t>Critical Role: a second look</a:t>
             </a:r>
           </a:p>
         </p:txBody>
@@ -6897,7 +5502,7 @@
           <p:cNvPr id="3" name="">
             <a:extLst xmlns:a="http://schemas.openxmlformats.org/drawingml/2006/main">
               <a:ext uri="{FF2B5EF4-FFF2-40B4-BE49-F238E27FC236}">
-                <a16:creationId xmlns:a16="http://schemas.microsoft.com/office/drawing/2014/main" id="{263B9D93-BD51-41C1-B7D3-511D7BA359B1}"/>
+                <a16:creationId xmlns:a16="http://schemas.microsoft.com/office/drawing/2014/main" id="{7CE7F5D5-FF04-4637-8E3D-4F4124D01CC2}"/>
               </a:ext>
             </a:extLst>
           </p:cNvPr>
@@ -6944,7 +5549,7 @@
                 <a:ea typeface="Noto Sans"/>
                 <a:cs typeface="Noto Sans"/>
               </a:rPr>
-              <a:t>One response, frozen at 3.0 seconds. Change only the crop</a:t>
+              <a:t>Revisit 7:28 to 8:38, inside the opening we watched earlier</a:t>
             </a:r>
           </a:p>
         </p:txBody>
@@ -6954,7 +5559,7 @@
           <p:cNvPr id="4" name="">
             <a:extLst xmlns:a="http://schemas.openxmlformats.org/drawingml/2006/main">
               <a:ext uri="{FF2B5EF4-FFF2-40B4-BE49-F238E27FC236}">
-                <a16:creationId xmlns:a16="http://schemas.microsoft.com/office/drawing/2014/main" id="{613962E2-3B8A-4C46-9227-F10923345ED3}"/>
+                <a16:creationId xmlns:a16="http://schemas.microsoft.com/office/drawing/2014/main" id="{1A642723-BCCE-4C58-BA9A-4A27B7C368F2}"/>
               </a:ext>
             </a:extLst>
           </p:cNvPr>
@@ -7001,7 +5606,7 @@
                 <a:ea typeface="Noto Sans"/>
                 <a:cs typeface="Noto Sans"/>
               </a:rPr>
-              <a:t>• What becomes easier to inspect?</a:t>
+              <a:t>• Name the visible action before interpreting it</a:t>
             </a:r>
           </a:p>
           <a:p xmlns:a="http://schemas.openxmlformats.org/drawingml/2006/main">
@@ -7024,7 +5629,7 @@
                 <a:ea typeface="Noto Sans"/>
                 <a:cs typeface="Noto Sans"/>
               </a:rPr>
-              <a:t>• What spatial evidence disappears?</a:t>
+              <a:t>• Does the longer opening support a repeated pattern?</a:t>
             </a:r>
           </a:p>
         </p:txBody>
@@ -7034,7 +5639,7 @@
           <p:cNvPr id="5" name="">
             <a:extLst xmlns:a="http://schemas.openxmlformats.org/drawingml/2006/main">
               <a:ext uri="{FF2B5EF4-FFF2-40B4-BE49-F238E27FC236}">
-                <a16:creationId xmlns:a16="http://schemas.microsoft.com/office/drawing/2014/main" id="{CFD928CD-AA97-416C-9C61-674FA9B917F2}"/>
+                <a16:creationId xmlns:a16="http://schemas.microsoft.com/office/drawing/2014/main" id="{1C7CE4C2-0EAB-4064-9C61-3BF5AECBFCF6}"/>
               </a:ext>
             </a:extLst>
           </p:cNvPr>
@@ -7081,7 +5686,7 @@
                 <a:ea typeface="Noto Sans"/>
                 <a:cs typeface="Noto Sans"/>
               </a:rPr>
-              <a:t>Open Reaction shot (open from the classroom HTML)</a:t>
+              <a:t>Revisit Critical Role at 7:28 (open from the classroom HTML)</a:t>
             </a:r>
           </a:p>
         </p:txBody>
@@ -7091,7 +5696,7 @@
           <p:cNvPr id="6" name="">
             <a:extLst xmlns:a="http://schemas.openxmlformats.org/drawingml/2006/main">
               <a:ext uri="{FF2B5EF4-FFF2-40B4-BE49-F238E27FC236}">
-                <a16:creationId xmlns:a16="http://schemas.microsoft.com/office/drawing/2014/main" id="{8A132DA4-E95B-4245-A9F0-DE1461E1DC65}"/>
+                <a16:creationId xmlns:a16="http://schemas.microsoft.com/office/drawing/2014/main" id="{B704D826-388A-4BA5-8F94-CCF484408EC2}"/>
               </a:ext>
             </a:extLst>
           </p:cNvPr>
@@ -7146,7 +5751,7 @@
     </p:spTree>
     <p:extLst>
       <p:ext uri="{BB962C8B-B14F-4D97-AF65-F5344CB8AC3E}">
-        <p14:creationId xmlns:p14="http://schemas.microsoft.com/office/powerpoint/2010/main" val="297915925"/>
+        <p14:creationId xmlns:p14="http://schemas.microsoft.com/office/powerpoint/2010/main" val="190832034"/>
       </p:ext>
     </p:extLst>
   </p:cSld>
@@ -7177,7 +5782,7 @@
           <p:cNvPr id="7" name="">
             <a:extLst xmlns:a="http://schemas.openxmlformats.org/drawingml/2006/main">
               <a:ext uri="{FF2B5EF4-FFF2-40B4-BE49-F238E27FC236}">
-                <a16:creationId xmlns:a16="http://schemas.microsoft.com/office/drawing/2014/main" id="{F31CEC35-F979-4754-8477-7144B39648A4}"/>
+                <a16:creationId xmlns:a16="http://schemas.microsoft.com/office/drawing/2014/main" id="{BD1D76BD-B91A-4164-B2D6-C8854570289C}"/>
               </a:ext>
             </a:extLst>
           </p:cNvPr>
@@ -7224,7 +5829,7 @@
                 <a:ea typeface="Noto Sans"/>
                 <a:cs typeface="Noto Sans"/>
               </a:rPr>
-              <a:t>11:02 to 11:16  /  CTIN 290</a:t>
+              <a:t>11:38 to 11:50  /  CTIN 290</a:t>
             </a:r>
           </a:p>
         </p:txBody>
@@ -7234,7 +5839,7 @@
           <p:cNvPr id="2" name="">
             <a:extLst xmlns:a="http://schemas.openxmlformats.org/drawingml/2006/main">
               <a:ext uri="{FF2B5EF4-FFF2-40B4-BE49-F238E27FC236}">
-                <a16:creationId xmlns:a16="http://schemas.microsoft.com/office/drawing/2014/main" id="{9643156C-98C0-4116-8EED-49F0C9949440}"/>
+                <a16:creationId xmlns:a16="http://schemas.microsoft.com/office/drawing/2014/main" id="{F4CF8593-4B3B-4D6C-B3AE-970A286F1655}"/>
               </a:ext>
             </a:extLst>
           </p:cNvPr>
@@ -7291,7 +5896,7 @@
           <p:cNvPr id="3" name="">
             <a:extLst xmlns:a="http://schemas.openxmlformats.org/drawingml/2006/main">
               <a:ext uri="{FF2B5EF4-FFF2-40B4-BE49-F238E27FC236}">
-                <a16:creationId xmlns:a16="http://schemas.microsoft.com/office/drawing/2014/main" id="{440AFAF5-4253-41B4-A614-FF80A735101E}"/>
+                <a16:creationId xmlns:a16="http://schemas.microsoft.com/office/drawing/2014/main" id="{79C6DE87-A027-4A6D-9314-CFC90AB068D9}"/>
               </a:ext>
             </a:extLst>
           </p:cNvPr>
@@ -7338,7 +5943,7 @@
                 <a:ea typeface="Noto Sans"/>
                 <a:cs typeface="Noto Sans"/>
               </a:rPr>
-              <a:t>Choose what the player needs to perceive, then test it with another pair</a:t>
+              <a:t>Choose what a player can inspect during a moment of performance</a:t>
             </a:r>
           </a:p>
         </p:txBody>
@@ -7348,7 +5953,7 @@
           <p:cNvPr id="4" name="">
             <a:extLst xmlns:a="http://schemas.openxmlformats.org/drawingml/2006/main">
               <a:ext uri="{FF2B5EF4-FFF2-40B4-BE49-F238E27FC236}">
-                <a16:creationId xmlns:a16="http://schemas.microsoft.com/office/drawing/2014/main" id="{E8C5F0DF-ABC4-4DBC-867C-60F86FAFCB72}"/>
+                <a16:creationId xmlns:a16="http://schemas.microsoft.com/office/drawing/2014/main" id="{C00B8220-A7A2-4399-A8D5-88F5C26F2D17}"/>
               </a:ext>
             </a:extLst>
           </p:cNvPr>
@@ -7418,7 +6023,7 @@
                 <a:ea typeface="Noto Sans"/>
                 <a:cs typeface="Noto Sans"/>
               </a:rPr>
-              <a:t>• Name one gain, one cost, and one test</a:t>
+              <a:t>• What is the gain, the cost, and your test?</a:t>
             </a:r>
           </a:p>
         </p:txBody>
@@ -7428,7 +6033,7 @@
           <p:cNvPr id="5" name="">
             <a:extLst xmlns:a="http://schemas.openxmlformats.org/drawingml/2006/main">
               <a:ext uri="{FF2B5EF4-FFF2-40B4-BE49-F238E27FC236}">
-                <a16:creationId xmlns:a16="http://schemas.microsoft.com/office/drawing/2014/main" id="{F400860C-C82D-473C-AD54-F79F18872FF4}"/>
+                <a16:creationId xmlns:a16="http://schemas.microsoft.com/office/drawing/2014/main" id="{38EA09A1-511C-4AFC-B9E4-A02AC069F3CD}"/>
               </a:ext>
             </a:extLst>
           </p:cNvPr>
@@ -7475,7 +6080,7 @@
                 <a:ea typeface="Noto Sans"/>
                 <a:cs typeface="Noto Sans"/>
               </a:rPr>
-              <a:t>Open the frozen response (open from the classroom HTML)</a:t>
+              <a:t>Compare the camera crops (open from the classroom HTML)</a:t>
             </a:r>
           </a:p>
         </p:txBody>
@@ -7485,7 +6090,7 @@
           <p:cNvPr id="6" name="">
             <a:extLst xmlns:a="http://schemas.openxmlformats.org/drawingml/2006/main">
               <a:ext uri="{FF2B5EF4-FFF2-40B4-BE49-F238E27FC236}">
-                <a16:creationId xmlns:a16="http://schemas.microsoft.com/office/drawing/2014/main" id="{43FFA744-4630-4940-B7E8-1BD627184AE8}"/>
+                <a16:creationId xmlns:a16="http://schemas.microsoft.com/office/drawing/2014/main" id="{6981F2E8-907E-483D-A0CD-374F3FB98D15}"/>
               </a:ext>
             </a:extLst>
           </p:cNvPr>
@@ -7540,7 +6145,7 @@
     </p:spTree>
     <p:extLst>
       <p:ext uri="{BB962C8B-B14F-4D97-AF65-F5344CB8AC3E}">
-        <p14:creationId xmlns:p14="http://schemas.microsoft.com/office/powerpoint/2010/main" val="1636959454"/>
+        <p14:creationId xmlns:p14="http://schemas.microsoft.com/office/powerpoint/2010/main" val="1210350222"/>
       </p:ext>
     </p:extLst>
   </p:cSld>
@@ -7571,7 +6176,7 @@
           <p:cNvPr id="7" name="">
             <a:extLst xmlns:a="http://schemas.openxmlformats.org/drawingml/2006/main">
               <a:ext uri="{FF2B5EF4-FFF2-40B4-BE49-F238E27FC236}">
-                <a16:creationId xmlns:a16="http://schemas.microsoft.com/office/drawing/2014/main" id="{E32C9735-75B2-4A3D-B684-81556459F3AE}"/>
+                <a16:creationId xmlns:a16="http://schemas.microsoft.com/office/drawing/2014/main" id="{EACCFC87-7611-4FC8-A113-ACB6AB9C7737}"/>
               </a:ext>
             </a:extLst>
           </p:cNvPr>
@@ -7618,7 +6223,7 @@
                 <a:ea typeface="Noto Sans"/>
                 <a:cs typeface="Noto Sans"/>
               </a:rPr>
-              <a:t>11:16 to 11:30  /  CTIN 290</a:t>
+              <a:t>11:50 to 11:55  /  CTIN 290</a:t>
             </a:r>
           </a:p>
         </p:txBody>
@@ -7628,7 +6233,7 @@
           <p:cNvPr id="2" name="">
             <a:extLst xmlns:a="http://schemas.openxmlformats.org/drawingml/2006/main">
               <a:ext uri="{FF2B5EF4-FFF2-40B4-BE49-F238E27FC236}">
-                <a16:creationId xmlns:a16="http://schemas.microsoft.com/office/drawing/2014/main" id="{11B68F84-5DBE-4D03-8DC6-808BD5BF75B2}"/>
+                <a16:creationId xmlns:a16="http://schemas.microsoft.com/office/drawing/2014/main" id="{205BB79B-9F18-47DB-964B-5FC969BE2F45}"/>
               </a:ext>
             </a:extLst>
           </p:cNvPr>
@@ -7675,7 +6280,7 @@
                 <a:ea typeface="Noto Sans"/>
                 <a:cs typeface="Noto Sans"/>
               </a:rPr>
-              <a:t>One World, Two Media · evidence rehearsal</a:t>
+              <a:t>One World, Two Media</a:t>
             </a:r>
           </a:p>
         </p:txBody>
@@ -7685,7 +6290,7 @@
           <p:cNvPr id="3" name="">
             <a:extLst xmlns:a="http://schemas.openxmlformats.org/drawingml/2006/main">
               <a:ext uri="{FF2B5EF4-FFF2-40B4-BE49-F238E27FC236}">
-                <a16:creationId xmlns:a16="http://schemas.microsoft.com/office/drawing/2014/main" id="{96FEE84F-EBCE-4180-989B-07D2AD40924D}"/>
+                <a16:creationId xmlns:a16="http://schemas.microsoft.com/office/drawing/2014/main" id="{45EA2A75-3B3B-48C9-8040-8B30B004030E}"/>
               </a:ext>
             </a:extLst>
           </p:cNvPr>
@@ -7732,7 +6337,7 @@
                 <a:ea typeface="Noto Sans"/>
                 <a:cs typeface="Noto Sans"/>
               </a:rPr>
-              <a:t>Show both versions. Speak over both. Let visible evidence support the comparison</a:t>
+              <a:t>Your 3 to 5 minute video essay compares the same story or world across two media</a:t>
             </a:r>
           </a:p>
         </p:txBody>
@@ -7742,7 +6347,7 @@
           <p:cNvPr id="4" name="">
             <a:extLst xmlns:a="http://schemas.openxmlformats.org/drawingml/2006/main">
               <a:ext uri="{FF2B5EF4-FFF2-40B4-BE49-F238E27FC236}">
-                <a16:creationId xmlns:a16="http://schemas.microsoft.com/office/drawing/2014/main" id="{FBF253FF-7714-4A40-93C5-A8B3E5C32DD8}"/>
+                <a16:creationId xmlns:a16="http://schemas.microsoft.com/office/drawing/2014/main" id="{66A5254C-F780-4798-BE20-784DB16232D9}"/>
               </a:ext>
             </a:extLst>
           </p:cNvPr>
@@ -7789,7 +6394,7 @@
                 <a:ea typeface="Noto Sans"/>
                 <a:cs typeface="Noto Sans"/>
               </a:rPr>
-              <a:t>• Survives / Reinvented / Gone</a:t>
+              <a:t>• Show both versions and speak over both</a:t>
             </a:r>
           </a:p>
           <a:p xmlns:a="http://schemas.openxmlformats.org/drawingml/2006/main">
@@ -7812,7 +6417,7 @@
                 <a:ea typeface="Noto Sans"/>
                 <a:cs typeface="Noto Sans"/>
               </a:rPr>
-              <a:t>• Due September 24, 5 PM Pacific</a:t>
+              <a:t>• Due Thursday September 24, 5 PM Pacific</a:t>
             </a:r>
           </a:p>
         </p:txBody>
@@ -7822,7 +6427,7 @@
           <p:cNvPr id="5" name="">
             <a:extLst xmlns:a="http://schemas.openxmlformats.org/drawingml/2006/main">
               <a:ext uri="{FF2B5EF4-FFF2-40B4-BE49-F238E27FC236}">
-                <a16:creationId xmlns:a16="http://schemas.microsoft.com/office/drawing/2014/main" id="{6CE2FE72-C2A8-4CD3-BCF1-6ADD640A9497}"/>
+                <a16:creationId xmlns:a16="http://schemas.microsoft.com/office/drawing/2014/main" id="{72881F64-9DD3-4F27-AEA8-60920CB819EB}"/>
               </a:ext>
             </a:extLst>
           </p:cNvPr>
@@ -7879,7 +6484,7 @@
           <p:cNvPr id="6" name="">
             <a:extLst xmlns:a="http://schemas.openxmlformats.org/drawingml/2006/main">
               <a:ext uri="{FF2B5EF4-FFF2-40B4-BE49-F238E27FC236}">
-                <a16:creationId xmlns:a16="http://schemas.microsoft.com/office/drawing/2014/main" id="{D61658EB-69A1-458C-9A45-B9749547D5D3}"/>
+                <a16:creationId xmlns:a16="http://schemas.microsoft.com/office/drawing/2014/main" id="{B7138215-6F2E-447C-B636-9462CC91DD77}"/>
               </a:ext>
             </a:extLst>
           </p:cNvPr>
@@ -7934,7 +6539,7 @@
     </p:spTree>
     <p:extLst>
       <p:ext uri="{BB962C8B-B14F-4D97-AF65-F5344CB8AC3E}">
-        <p14:creationId xmlns:p14="http://schemas.microsoft.com/office/powerpoint/2010/main" val="1526662484"/>
+        <p14:creationId xmlns:p14="http://schemas.microsoft.com/office/powerpoint/2010/main" val="156265620"/>
       </p:ext>
     </p:extLst>
   </p:cSld>

</xml_diff>